<commit_message>
update Chapter 1 pipeline PPTX to minimalist Times New Roman academic style
- Simplified to exactly 2 slides: Slide 1 (Chinese) and Slide 2 (English)
- Adopted pure white background, black text, thin black borders, and Times New Roman font
- Refined horizontal four-phase layout mapping all 9 proposal chapters

Co-authored-by: Cursor <cursoragent@cursor.com>
</commit_message>
<xml_diff>
--- a/Chapter01_Overall_Pipeline.pptx
+++ b/Chapter01_Overall_Pipeline.pptx
@@ -7,7 +7,6 @@
   <p:sldIdLst>
     <p:sldId id="256" r:id="rId7"/>
     <p:sldId id="257" r:id="rId8"/>
-    <p:sldId id="258" r:id="rId9"/>
   </p:sldIdLst>
   <p:sldSz cx="12191695" cy="6858000" type="screen4x3"/>
   <p:notesSz cx="6858000" cy="9144000"/>
@@ -3098,8 +3097,8 @@
         </p:nvSpPr>
         <p:spPr>
           <a:xfrm>
-            <a:off x="731520" y="365760"/>
-            <a:ext cx="10728655" cy="822960"/>
+            <a:off x="731520" y="411480"/>
+            <a:ext cx="10728655" cy="777240"/>
           </a:xfrm>
           <a:prstGeom prst="rect">
             <a:avLst/>
@@ -3115,26 +3114,26 @@
             <a:pPr>
               <a:defRPr sz="2200" b="1">
                 <a:solidFill>
-                  <a:srgbClr val="1A202C"/>
-                </a:solidFill>
-                <a:latin typeface="Arial"/>
+                  <a:srgbClr val="000000"/>
+                </a:solidFill>
+                <a:latin typeface="Times New Roman"/>
               </a:defRPr>
             </a:pPr>
             <a:r>
-              <a:t>专著整体框架与章节映射流程图 (Overall Framework &amp; Chapter Structure)</a:t>
+              <a:t>专著总体框架与章节结构图</a:t>
             </a:r>
           </a:p>
           <a:p>
             <a:pPr>
               <a:defRPr sz="1200">
                 <a:solidFill>
-                  <a:srgbClr val="4A5568"/>
-                </a:solidFill>
-                <a:latin typeface="Microsoft YaHei"/>
+                  <a:srgbClr val="5A5A5A"/>
+                </a:solidFill>
+                <a:latin typeface="Times New Roman"/>
               </a:defRPr>
             </a:pPr>
             <a:r>
-              <a:t>书名: AI-Driven UAV Building Inspection: An End-to-End Framework from Autonomous Flight to Digital Twins (第1章导论映射)</a:t>
+              <a:t>AI-Driven UAV Building Inspection: An End-to-End Framework from Autonomous Flight to Digital Twins</a:t>
             </a:r>
           </a:p>
         </p:txBody>
@@ -3148,17 +3147,17 @@
         <p:spPr>
           <a:xfrm>
             <a:off x="731520" y="1371600"/>
-            <a:ext cx="2468880" cy="4663440"/>
+            <a:ext cx="2423160" cy="457200"/>
           </a:xfrm>
           <a:prstGeom prst="rect">
             <a:avLst/>
           </a:prstGeom>
           <a:solidFill>
-            <a:srgbClr val="F8FAFC"/>
+            <a:srgbClr val="FFFFFF"/>
           </a:solidFill>
-          <a:ln w="19050">
+          <a:ln w="15875">
             <a:solidFill>
-              <a:srgbClr val="94A3B8"/>
+              <a:srgbClr val="000000"/>
             </a:solidFill>
           </a:ln>
         </p:spPr>
@@ -3180,7 +3179,17 @@
           <a:bodyPr rtlCol="0" anchor="ctr"/>
           <a:lstStyle/>
           <a:p>
-            <a:pPr algn="ctr"/>
+            <a:pPr algn="ctr">
+              <a:defRPr sz="1100" b="1">
+                <a:solidFill>
+                  <a:srgbClr val="000000"/>
+                </a:solidFill>
+                <a:latin typeface="Times New Roman"/>
+              </a:defRPr>
+            </a:pPr>
+            <a:r>
+              <a:t>阶段一：自主采集与规划</a:t>
+            </a:r>
           </a:p>
         </p:txBody>
       </p:sp>
@@ -3192,63 +3201,10 @@
         </p:nvSpPr>
         <p:spPr>
           <a:xfrm>
-            <a:off x="731520" y="1371600"/>
-            <a:ext cx="2468880" cy="594360"/>
+            <a:off x="731520" y="1920240"/>
+            <a:ext cx="2423160" cy="2002536"/>
           </a:xfrm>
           <a:prstGeom prst="rect">
-            <a:avLst/>
-          </a:prstGeom>
-          <a:solidFill>
-            <a:srgbClr val="94A3B8"/>
-          </a:solidFill>
-          <a:ln>
-            <a:noFill/>
-          </a:ln>
-        </p:spPr>
-        <p:style>
-          <a:lnRef idx="1">
-            <a:schemeClr val="accent1"/>
-          </a:lnRef>
-          <a:fillRef idx="3">
-            <a:schemeClr val="accent1"/>
-          </a:fillRef>
-          <a:effectRef idx="2">
-            <a:schemeClr val="accent1"/>
-          </a:effectRef>
-          <a:fontRef idx="minor">
-            <a:schemeClr val="lt1"/>
-          </a:fontRef>
-        </p:style>
-        <p:txBody>
-          <a:bodyPr rtlCol="0" anchor="ctr" wrap="square"/>
-          <a:lstStyle/>
-          <a:p>
-            <a:pPr algn="ctr">
-              <a:defRPr sz="1100" b="1">
-                <a:solidFill>
-                  <a:srgbClr val="FFFFFF"/>
-                </a:solidFill>
-                <a:latin typeface="Microsoft YaHei"/>
-              </a:defRPr>
-            </a:pPr>
-            <a:r>
-              <a:t>阶段一: 自主飞行与数据采集</a:t>
-            </a:r>
-          </a:p>
-        </p:txBody>
-      </p:sp>
-      <p:sp>
-        <p:nvSpPr>
-          <p:cNvPr id="5" name="Rounded Rectangle 4"/>
-          <p:cNvSpPr/>
-          <p:nvPr/>
-        </p:nvSpPr>
-        <p:spPr>
-          <a:xfrm>
-            <a:off x="841248" y="2057400"/>
-            <a:ext cx="2249424" cy="1805940"/>
-          </a:xfrm>
-          <a:prstGeom prst="roundRect">
             <a:avLst/>
           </a:prstGeom>
           <a:solidFill>
@@ -3256,7 +3212,7 @@
           </a:solidFill>
           <a:ln w="12700">
             <a:solidFill>
-              <a:srgbClr val="CBD5E1"/>
+              <a:srgbClr val="000000"/>
             </a:solidFill>
           </a:ln>
         </p:spPr>
@@ -3275,48 +3231,55 @@
           </a:fontRef>
         </p:style>
         <p:txBody>
-          <a:bodyPr rtlCol="0" anchor="ctr" wrap="square" tIns="73152" bIns="73152"/>
+          <a:bodyPr rtlCol="0" anchor="t" wrap="square" lIns="109728" rIns="109728" tIns="109728"/>
           <a:lstStyle/>
           <a:p>
             <a:pPr algn="ctr">
-              <a:defRPr sz="1100" b="1">
-                <a:solidFill>
-                  <a:srgbClr val="1A202C"/>
-                </a:solidFill>
-                <a:latin typeface="Microsoft YaHei"/>
+              <a:spcAft>
+                <a:spcPts val="400"/>
+              </a:spcAft>
+              <a:defRPr sz="1050" b="1">
+                <a:solidFill>
+                  <a:srgbClr val="000000"/>
+                </a:solidFill>
+                <a:latin typeface="Times New Roman"/>
               </a:defRPr>
             </a:pPr>
             <a:r>
-              <a:t>【第 2 章】任务规划 (Task Planning)</a:t>
+              <a:t>第 2 章：任务规划</a:t>
             </a:r>
           </a:p>
           <a:p>
             <a:pPr>
               <a:defRPr sz="950">
                 <a:solidFill>
-                  <a:srgbClr val="4A5568"/>
-                </a:solidFill>
-                <a:latin typeface="Microsoft YaHei"/>
+                  <a:srgbClr val="000000"/>
+                </a:solidFill>
+                <a:latin typeface="Times New Roman"/>
               </a:defRPr>
             </a:pPr>
             <a:r>
-              <a:t>立面巡检覆盖规划 • ROI区域定义 • 多无人机路径生成</a:t>
-            </a:r>
-          </a:p>
-        </p:txBody>
-      </p:sp>
-      <p:sp>
-        <p:nvSpPr>
-          <p:cNvPr id="6" name="Rounded Rectangle 5"/>
+              <a:t>• 立面巡检覆盖路径规划</a:t>
+            </a:r>
+            <a:br/>
+            <a:r>
+              <a:t>• ROI 区域定义与多机协同</a:t>
+            </a:r>
+          </a:p>
+        </p:txBody>
+      </p:sp>
+      <p:sp>
+        <p:nvSpPr>
+          <p:cNvPr id="5" name="Rectangle 4"/>
           <p:cNvSpPr/>
           <p:nvPr/>
         </p:nvSpPr>
         <p:spPr>
           <a:xfrm>
-            <a:off x="841248" y="3954780"/>
-            <a:ext cx="2249424" cy="1805940"/>
-          </a:xfrm>
-          <a:prstGeom prst="roundRect">
+            <a:off x="731520" y="4032504"/>
+            <a:ext cx="2423160" cy="2002536"/>
+          </a:xfrm>
+          <a:prstGeom prst="rect">
             <a:avLst/>
           </a:prstGeom>
           <a:solidFill>
@@ -3324,7 +3287,7 @@
           </a:solidFill>
           <a:ln w="12700">
             <a:solidFill>
-              <a:srgbClr val="CBD5E1"/>
+              <a:srgbClr val="000000"/>
             </a:solidFill>
           </a:ln>
         </p:spPr>
@@ -3343,52 +3306,59 @@
           </a:fontRef>
         </p:style>
         <p:txBody>
-          <a:bodyPr rtlCol="0" anchor="ctr" wrap="square" tIns="73152" bIns="73152"/>
+          <a:bodyPr rtlCol="0" anchor="t" wrap="square" lIns="109728" rIns="109728" tIns="109728"/>
           <a:lstStyle/>
           <a:p>
             <a:pPr algn="ctr">
-              <a:defRPr sz="1100" b="1">
-                <a:solidFill>
-                  <a:srgbClr val="1A202C"/>
-                </a:solidFill>
-                <a:latin typeface="Microsoft YaHei"/>
+              <a:spcAft>
+                <a:spcPts val="400"/>
+              </a:spcAft>
+              <a:defRPr sz="1050" b="1">
+                <a:solidFill>
+                  <a:srgbClr val="000000"/>
+                </a:solidFill>
+                <a:latin typeface="Times New Roman"/>
               </a:defRPr>
             </a:pPr>
             <a:r>
-              <a:t>【第 3 章】运动规划与执行 (Motion Planning)</a:t>
+              <a:t>第 3 章：运动规划</a:t>
             </a:r>
           </a:p>
           <a:p>
             <a:pPr>
               <a:defRPr sz="950">
                 <a:solidFill>
-                  <a:srgbClr val="4A5568"/>
-                </a:solidFill>
-                <a:latin typeface="Microsoft YaHei"/>
+                  <a:srgbClr val="000000"/>
+                </a:solidFill>
+                <a:latin typeface="Times New Roman"/>
               </a:defRPr>
             </a:pPr>
             <a:r>
-              <a:t>实时避障 • 轨迹优化与控制 • 风场适应与自主飞行</a:t>
-            </a:r>
-          </a:p>
-        </p:txBody>
-      </p:sp>
-      <p:sp>
-        <p:nvSpPr>
-          <p:cNvPr id="7" name="Right Arrow 6"/>
+              <a:t>• 实时避障与轨迹优化</a:t>
+            </a:r>
+            <a:br/>
+            <a:r>
+              <a:t>• 风场扰动适应与自主控制</a:t>
+            </a:r>
+          </a:p>
+        </p:txBody>
+      </p:sp>
+      <p:sp>
+        <p:nvSpPr>
+          <p:cNvPr id="6" name="Right Arrow 5"/>
           <p:cNvSpPr/>
           <p:nvPr/>
         </p:nvSpPr>
         <p:spPr>
           <a:xfrm>
-            <a:off x="3246120" y="3566160"/>
-            <a:ext cx="182880" cy="274320"/>
+            <a:off x="3227832" y="3593592"/>
+            <a:ext cx="201168" cy="219456"/>
           </a:xfrm>
           <a:prstGeom prst="rightArrow">
             <a:avLst/>
           </a:prstGeom>
           <a:solidFill>
-            <a:srgbClr val="4A5568"/>
+            <a:srgbClr val="000000"/>
           </a:solidFill>
           <a:ln>
             <a:noFill/>
@@ -3418,24 +3388,24 @@
       </p:sp>
       <p:sp>
         <p:nvSpPr>
-          <p:cNvPr id="8" name="Rectangle 7"/>
+          <p:cNvPr id="7" name="Rectangle 6"/>
           <p:cNvSpPr/>
           <p:nvPr/>
         </p:nvSpPr>
         <p:spPr>
           <a:xfrm>
-            <a:off x="3474720" y="1371600"/>
-            <a:ext cx="2468880" cy="4663440"/>
+            <a:off x="3502152" y="1371600"/>
+            <a:ext cx="2423160" cy="457200"/>
           </a:xfrm>
           <a:prstGeom prst="rect">
             <a:avLst/>
           </a:prstGeom>
           <a:solidFill>
-            <a:srgbClr val="F8FAFC"/>
+            <a:srgbClr val="FFFFFF"/>
           </a:solidFill>
-          <a:ln w="19050">
+          <a:ln w="15875">
             <a:solidFill>
-              <a:srgbClr val="94A3B8"/>
+              <a:srgbClr val="000000"/>
             </a:solidFill>
           </a:ln>
         </p:spPr>
@@ -3457,75 +3427,32 @@
           <a:bodyPr rtlCol="0" anchor="ctr"/>
           <a:lstStyle/>
           <a:p>
-            <a:pPr algn="ctr"/>
-          </a:p>
-        </p:txBody>
-      </p:sp>
-      <p:sp>
-        <p:nvSpPr>
-          <p:cNvPr id="9" name="Rectangle 8"/>
+            <a:pPr algn="ctr">
+              <a:defRPr sz="1100" b="1">
+                <a:solidFill>
+                  <a:srgbClr val="000000"/>
+                </a:solidFill>
+                <a:latin typeface="Times New Roman"/>
+              </a:defRPr>
+            </a:pPr>
+            <a:r>
+              <a:t>阶段二：重建与数据表达</a:t>
+            </a:r>
+          </a:p>
+        </p:txBody>
+      </p:sp>
+      <p:sp>
+        <p:nvSpPr>
+          <p:cNvPr id="8" name="Rectangle 7"/>
           <p:cNvSpPr/>
           <p:nvPr/>
         </p:nvSpPr>
         <p:spPr>
           <a:xfrm>
-            <a:off x="3474720" y="1371600"/>
-            <a:ext cx="2468880" cy="594360"/>
+            <a:off x="3502152" y="1920240"/>
+            <a:ext cx="2423160" cy="2002536"/>
           </a:xfrm>
           <a:prstGeom prst="rect">
-            <a:avLst/>
-          </a:prstGeom>
-          <a:solidFill>
-            <a:srgbClr val="94A3B8"/>
-          </a:solidFill>
-          <a:ln>
-            <a:noFill/>
-          </a:ln>
-        </p:spPr>
-        <p:style>
-          <a:lnRef idx="1">
-            <a:schemeClr val="accent1"/>
-          </a:lnRef>
-          <a:fillRef idx="3">
-            <a:schemeClr val="accent1"/>
-          </a:fillRef>
-          <a:effectRef idx="2">
-            <a:schemeClr val="accent1"/>
-          </a:effectRef>
-          <a:fontRef idx="minor">
-            <a:schemeClr val="lt1"/>
-          </a:fontRef>
-        </p:style>
-        <p:txBody>
-          <a:bodyPr rtlCol="0" anchor="ctr" wrap="square"/>
-          <a:lstStyle/>
-          <a:p>
-            <a:pPr algn="ctr">
-              <a:defRPr sz="1100" b="1">
-                <a:solidFill>
-                  <a:srgbClr val="FFFFFF"/>
-                </a:solidFill>
-                <a:latin typeface="Microsoft YaHei"/>
-              </a:defRPr>
-            </a:pPr>
-            <a:r>
-              <a:t>阶段二: 空间重建与数据表达</a:t>
-            </a:r>
-          </a:p>
-        </p:txBody>
-      </p:sp>
-      <p:sp>
-        <p:nvSpPr>
-          <p:cNvPr id="10" name="Rounded Rectangle 9"/>
-          <p:cNvSpPr/>
-          <p:nvPr/>
-        </p:nvSpPr>
-        <p:spPr>
-          <a:xfrm>
-            <a:off x="3584448" y="2057400"/>
-            <a:ext cx="2249424" cy="1805940"/>
-          </a:xfrm>
-          <a:prstGeom prst="roundRect">
             <a:avLst/>
           </a:prstGeom>
           <a:solidFill>
@@ -3533,7 +3460,7 @@
           </a:solidFill>
           <a:ln w="12700">
             <a:solidFill>
-              <a:srgbClr val="CBD5E1"/>
+              <a:srgbClr val="000000"/>
             </a:solidFill>
           </a:ln>
         </p:spPr>
@@ -3552,48 +3479,55 @@
           </a:fontRef>
         </p:style>
         <p:txBody>
-          <a:bodyPr rtlCol="0" anchor="ctr" wrap="square" tIns="73152" bIns="73152"/>
+          <a:bodyPr rtlCol="0" anchor="t" wrap="square" lIns="109728" rIns="109728" tIns="109728"/>
           <a:lstStyle/>
           <a:p>
             <a:pPr algn="ctr">
-              <a:defRPr sz="1100" b="1">
-                <a:solidFill>
-                  <a:srgbClr val="1A202C"/>
-                </a:solidFill>
-                <a:latin typeface="Microsoft YaHei"/>
+              <a:spcAft>
+                <a:spcPts val="400"/>
+              </a:spcAft>
+              <a:defRPr sz="1050" b="1">
+                <a:solidFill>
+                  <a:srgbClr val="000000"/>
+                </a:solidFill>
+                <a:latin typeface="Times New Roman"/>
               </a:defRPr>
             </a:pPr>
             <a:r>
-              <a:t>【第 4 章】3D重建与资产映射 (3D Reconstruction)</a:t>
+              <a:t>第 4 章：三维重建</a:t>
             </a:r>
           </a:p>
           <a:p>
             <a:pPr>
               <a:defRPr sz="950">
                 <a:solidFill>
-                  <a:srgbClr val="4A5568"/>
-                </a:solidFill>
-                <a:latin typeface="Microsoft YaHei"/>
+                  <a:srgbClr val="000000"/>
+                </a:solidFill>
+                <a:latin typeface="Times New Roman"/>
               </a:defRPr>
             </a:pPr>
             <a:r>
-              <a:t>摄影测量 • 点云与网格建模 • BIM/坐标系精准对齐</a:t>
-            </a:r>
-          </a:p>
-        </p:txBody>
-      </p:sp>
-      <p:sp>
-        <p:nvSpPr>
-          <p:cNvPr id="11" name="Rounded Rectangle 10"/>
+              <a:t>• 倾斜摄影测量与点云建模</a:t>
+            </a:r>
+            <a:br/>
+            <a:r>
+              <a:t>• Mesh 构网与 BIM 坐标对齐</a:t>
+            </a:r>
+          </a:p>
+        </p:txBody>
+      </p:sp>
+      <p:sp>
+        <p:nvSpPr>
+          <p:cNvPr id="9" name="Rectangle 8"/>
           <p:cNvSpPr/>
           <p:nvPr/>
         </p:nvSpPr>
         <p:spPr>
           <a:xfrm>
-            <a:off x="3584448" y="3954780"/>
-            <a:ext cx="2249424" cy="1805940"/>
-          </a:xfrm>
-          <a:prstGeom prst="roundRect">
+            <a:off x="3502152" y="4032504"/>
+            <a:ext cx="2423160" cy="2002536"/>
+          </a:xfrm>
+          <a:prstGeom prst="rect">
             <a:avLst/>
           </a:prstGeom>
           <a:solidFill>
@@ -3601,7 +3535,7 @@
           </a:solidFill>
           <a:ln w="12700">
             <a:solidFill>
-              <a:srgbClr val="CBD5E1"/>
+              <a:srgbClr val="000000"/>
             </a:solidFill>
           </a:ln>
         </p:spPr>
@@ -3620,52 +3554,59 @@
           </a:fontRef>
         </p:style>
         <p:txBody>
-          <a:bodyPr rtlCol="0" anchor="ctr" wrap="square" tIns="73152" bIns="73152"/>
+          <a:bodyPr rtlCol="0" anchor="t" wrap="square" lIns="109728" rIns="109728" tIns="109728"/>
           <a:lstStyle/>
           <a:p>
             <a:pPr algn="ctr">
-              <a:defRPr sz="1100" b="1">
-                <a:solidFill>
-                  <a:srgbClr val="1A202C"/>
-                </a:solidFill>
-                <a:latin typeface="Microsoft YaHei"/>
+              <a:spcAft>
+                <a:spcPts val="400"/>
+              </a:spcAft>
+              <a:defRPr sz="1050" b="1">
+                <a:solidFill>
+                  <a:srgbClr val="000000"/>
+                </a:solidFill>
+                <a:latin typeface="Times New Roman"/>
               </a:defRPr>
             </a:pPr>
             <a:r>
-              <a:t>【第 5 章】巡检数据集与多模态数据 (Datasets)</a:t>
+              <a:t>第 5 章：巡检数据集</a:t>
             </a:r>
           </a:p>
           <a:p>
             <a:pPr>
               <a:defRPr sz="950">
                 <a:solidFill>
-                  <a:srgbClr val="4A5568"/>
-                </a:solidFill>
-                <a:latin typeface="Microsoft YaHei"/>
+                  <a:srgbClr val="000000"/>
+                </a:solidFill>
+                <a:latin typeface="Times New Roman"/>
               </a:defRPr>
             </a:pPr>
             <a:r>
-              <a:t>RGB/热成像数据采集 • 缺陷标注规范 • 基准集构建</a:t>
-            </a:r>
-          </a:p>
-        </p:txBody>
-      </p:sp>
-      <p:sp>
-        <p:nvSpPr>
-          <p:cNvPr id="12" name="Right Arrow 11"/>
+              <a:t>• RGB / 热成像多模态采集</a:t>
+            </a:r>
+            <a:br/>
+            <a:r>
+              <a:t>• 缺陷标注规范与基准集</a:t>
+            </a:r>
+          </a:p>
+        </p:txBody>
+      </p:sp>
+      <p:sp>
+        <p:nvSpPr>
+          <p:cNvPr id="10" name="Right Arrow 9"/>
           <p:cNvSpPr/>
           <p:nvPr/>
         </p:nvSpPr>
         <p:spPr>
           <a:xfrm>
-            <a:off x="5989320" y="3566160"/>
-            <a:ext cx="182880" cy="274320"/>
+            <a:off x="5998464" y="3593592"/>
+            <a:ext cx="201168" cy="219456"/>
           </a:xfrm>
           <a:prstGeom prst="rightArrow">
             <a:avLst/>
           </a:prstGeom>
           <a:solidFill>
-            <a:srgbClr val="4A5568"/>
+            <a:srgbClr val="000000"/>
           </a:solidFill>
           <a:ln>
             <a:noFill/>
@@ -3695,24 +3636,24 @@
       </p:sp>
       <p:sp>
         <p:nvSpPr>
-          <p:cNvPr id="13" name="Rectangle 12"/>
+          <p:cNvPr id="11" name="Rectangle 10"/>
           <p:cNvSpPr/>
           <p:nvPr/>
         </p:nvSpPr>
         <p:spPr>
           <a:xfrm>
-            <a:off x="6217920" y="1371600"/>
-            <a:ext cx="2468880" cy="4663440"/>
+            <a:off x="6272784" y="1371600"/>
+            <a:ext cx="2423160" cy="457200"/>
           </a:xfrm>
           <a:prstGeom prst="rect">
             <a:avLst/>
           </a:prstGeom>
           <a:solidFill>
-            <a:srgbClr val="F8FAFC"/>
+            <a:srgbClr val="FFFFFF"/>
           </a:solidFill>
-          <a:ln w="19050">
+          <a:ln w="15875">
             <a:solidFill>
-              <a:srgbClr val="94A3B8"/>
+              <a:srgbClr val="000000"/>
             </a:solidFill>
           </a:ln>
         </p:spPr>
@@ -3734,75 +3675,32 @@
           <a:bodyPr rtlCol="0" anchor="ctr"/>
           <a:lstStyle/>
           <a:p>
-            <a:pPr algn="ctr"/>
-          </a:p>
-        </p:txBody>
-      </p:sp>
-      <p:sp>
-        <p:nvSpPr>
-          <p:cNvPr id="14" name="Rectangle 13"/>
+            <a:pPr algn="ctr">
+              <a:defRPr sz="1100" b="1">
+                <a:solidFill>
+                  <a:srgbClr val="000000"/>
+                </a:solidFill>
+                <a:latin typeface="Times New Roman"/>
+              </a:defRPr>
+            </a:pPr>
+            <a:r>
+              <a:t>阶段三：AI 缺陷感知</a:t>
+            </a:r>
+          </a:p>
+        </p:txBody>
+      </p:sp>
+      <p:sp>
+        <p:nvSpPr>
+          <p:cNvPr id="12" name="Rectangle 11"/>
           <p:cNvSpPr/>
           <p:nvPr/>
         </p:nvSpPr>
         <p:spPr>
           <a:xfrm>
-            <a:off x="6217920" y="1371600"/>
-            <a:ext cx="2468880" cy="594360"/>
+            <a:off x="6272784" y="1920240"/>
+            <a:ext cx="2423160" cy="4114800"/>
           </a:xfrm>
           <a:prstGeom prst="rect">
-            <a:avLst/>
-          </a:prstGeom>
-          <a:solidFill>
-            <a:srgbClr val="94A3B8"/>
-          </a:solidFill>
-          <a:ln>
-            <a:noFill/>
-          </a:ln>
-        </p:spPr>
-        <p:style>
-          <a:lnRef idx="1">
-            <a:schemeClr val="accent1"/>
-          </a:lnRef>
-          <a:fillRef idx="3">
-            <a:schemeClr val="accent1"/>
-          </a:fillRef>
-          <a:effectRef idx="2">
-            <a:schemeClr val="accent1"/>
-          </a:effectRef>
-          <a:fontRef idx="minor">
-            <a:schemeClr val="lt1"/>
-          </a:fontRef>
-        </p:style>
-        <p:txBody>
-          <a:bodyPr rtlCol="0" anchor="ctr" wrap="square"/>
-          <a:lstStyle/>
-          <a:p>
-            <a:pPr algn="ctr">
-              <a:defRPr sz="1100" b="1">
-                <a:solidFill>
-                  <a:srgbClr val="FFFFFF"/>
-                </a:solidFill>
-                <a:latin typeface="Microsoft YaHei"/>
-              </a:defRPr>
-            </a:pPr>
-            <a:r>
-              <a:t>阶段三: AI 缺陷感知与分析</a:t>
-            </a:r>
-          </a:p>
-        </p:txBody>
-      </p:sp>
-      <p:sp>
-        <p:nvSpPr>
-          <p:cNvPr id="15" name="Rounded Rectangle 14"/>
-          <p:cNvSpPr/>
-          <p:nvPr/>
-        </p:nvSpPr>
-        <p:spPr>
-          <a:xfrm>
-            <a:off x="6327648" y="2057400"/>
-            <a:ext cx="2249424" cy="3886200"/>
-          </a:xfrm>
-          <a:prstGeom prst="roundRect">
             <a:avLst/>
           </a:prstGeom>
           <a:solidFill>
@@ -3810,7 +3708,7 @@
           </a:solidFill>
           <a:ln w="12700">
             <a:solidFill>
-              <a:srgbClr val="CBD5E1"/>
+              <a:srgbClr val="000000"/>
             </a:solidFill>
           </a:ln>
         </p:spPr>
@@ -3829,52 +3727,63 @@
           </a:fontRef>
         </p:style>
         <p:txBody>
-          <a:bodyPr rtlCol="0" anchor="ctr" wrap="square" tIns="73152" bIns="73152"/>
+          <a:bodyPr rtlCol="0" anchor="t" wrap="square" lIns="109728" rIns="109728" tIns="109728"/>
           <a:lstStyle/>
           <a:p>
             <a:pPr algn="ctr">
-              <a:defRPr sz="1100" b="1">
-                <a:solidFill>
-                  <a:srgbClr val="1A202C"/>
-                </a:solidFill>
-                <a:latin typeface="Microsoft YaHei"/>
+              <a:spcAft>
+                <a:spcPts val="400"/>
+              </a:spcAft>
+              <a:defRPr sz="1050" b="1">
+                <a:solidFill>
+                  <a:srgbClr val="000000"/>
+                </a:solidFill>
+                <a:latin typeface="Times New Roman"/>
               </a:defRPr>
             </a:pPr>
             <a:r>
-              <a:t>【第 6 章】缺陷检测 AI 模型 (AI Defect Models)</a:t>
+              <a:t>第 6 章：AI 缺陷检测模型</a:t>
             </a:r>
           </a:p>
           <a:p>
             <a:pPr>
               <a:defRPr sz="950">
                 <a:solidFill>
-                  <a:srgbClr val="4A5568"/>
-                </a:solidFill>
-                <a:latin typeface="Microsoft YaHei"/>
+                  <a:srgbClr val="000000"/>
+                </a:solidFill>
+                <a:latin typeface="Times New Roman"/>
               </a:defRPr>
             </a:pPr>
             <a:r>
-              <a:t>深度学习检测器 • 实例分割 • 缺陷面积与程度量化</a:t>
-            </a:r>
-          </a:p>
-        </p:txBody>
-      </p:sp>
-      <p:sp>
-        <p:nvSpPr>
-          <p:cNvPr id="16" name="Right Arrow 15"/>
+              <a:t>• 深度学习目标检测</a:t>
+            </a:r>
+            <a:br/>
+            <a:r>
+              <a:t>• 构件实例分割与定量量化</a:t>
+            </a:r>
+            <a:br/>
+            <a:r>
+              <a:t>• 缺陷严重程度评估</a:t>
+            </a:r>
+          </a:p>
+        </p:txBody>
+      </p:sp>
+      <p:sp>
+        <p:nvSpPr>
+          <p:cNvPr id="13" name="Right Arrow 12"/>
           <p:cNvSpPr/>
           <p:nvPr/>
         </p:nvSpPr>
         <p:spPr>
           <a:xfrm>
-            <a:off x="8732520" y="3566160"/>
-            <a:ext cx="182880" cy="274320"/>
+            <a:off x="8769096" y="3593592"/>
+            <a:ext cx="201168" cy="219456"/>
           </a:xfrm>
           <a:prstGeom prst="rightArrow">
             <a:avLst/>
           </a:prstGeom>
           <a:solidFill>
-            <a:srgbClr val="4A5568"/>
+            <a:srgbClr val="000000"/>
           </a:solidFill>
           <a:ln>
             <a:noFill/>
@@ -3904,24 +3813,24 @@
       </p:sp>
       <p:sp>
         <p:nvSpPr>
-          <p:cNvPr id="17" name="Rectangle 16"/>
+          <p:cNvPr id="14" name="Rectangle 13"/>
           <p:cNvSpPr/>
           <p:nvPr/>
         </p:nvSpPr>
         <p:spPr>
           <a:xfrm>
-            <a:off x="8961120" y="1371600"/>
-            <a:ext cx="2468880" cy="4663440"/>
+            <a:off x="9043416" y="1371600"/>
+            <a:ext cx="2423160" cy="457200"/>
           </a:xfrm>
           <a:prstGeom prst="rect">
             <a:avLst/>
           </a:prstGeom>
           <a:solidFill>
-            <a:srgbClr val="F1F5F9"/>
+            <a:srgbClr val="FFFFFF"/>
           </a:solidFill>
-          <a:ln w="19050">
+          <a:ln w="15875">
             <a:solidFill>
-              <a:srgbClr val="475569"/>
+              <a:srgbClr val="000000"/>
             </a:solidFill>
           </a:ln>
         </p:spPr>
@@ -3943,75 +3852,32 @@
           <a:bodyPr rtlCol="0" anchor="ctr"/>
           <a:lstStyle/>
           <a:p>
-            <a:pPr algn="ctr"/>
-          </a:p>
-        </p:txBody>
-      </p:sp>
-      <p:sp>
-        <p:nvSpPr>
-          <p:cNvPr id="18" name="Rectangle 17"/>
+            <a:pPr algn="ctr">
+              <a:defRPr sz="1100" b="1">
+                <a:solidFill>
+                  <a:srgbClr val="000000"/>
+                </a:solidFill>
+                <a:latin typeface="Times New Roman"/>
+              </a:defRPr>
+            </a:pPr>
+            <a:r>
+              <a:t>阶段四：数字孪生与决策</a:t>
+            </a:r>
+          </a:p>
+        </p:txBody>
+      </p:sp>
+      <p:sp>
+        <p:nvSpPr>
+          <p:cNvPr id="15" name="Rectangle 14"/>
           <p:cNvSpPr/>
           <p:nvPr/>
         </p:nvSpPr>
         <p:spPr>
           <a:xfrm>
-            <a:off x="8961120" y="1371600"/>
-            <a:ext cx="2468880" cy="594360"/>
+            <a:off x="9043416" y="1920240"/>
+            <a:ext cx="2423160" cy="1298448"/>
           </a:xfrm>
           <a:prstGeom prst="rect">
-            <a:avLst/>
-          </a:prstGeom>
-          <a:solidFill>
-            <a:srgbClr val="475569"/>
-          </a:solidFill>
-          <a:ln>
-            <a:noFill/>
-          </a:ln>
-        </p:spPr>
-        <p:style>
-          <a:lnRef idx="1">
-            <a:schemeClr val="accent1"/>
-          </a:lnRef>
-          <a:fillRef idx="3">
-            <a:schemeClr val="accent1"/>
-          </a:fillRef>
-          <a:effectRef idx="2">
-            <a:schemeClr val="accent1"/>
-          </a:effectRef>
-          <a:fontRef idx="minor">
-            <a:schemeClr val="lt1"/>
-          </a:fontRef>
-        </p:style>
-        <p:txBody>
-          <a:bodyPr rtlCol="0" anchor="ctr" wrap="square"/>
-          <a:lstStyle/>
-          <a:p>
-            <a:pPr algn="ctr">
-              <a:defRPr sz="1100" b="1">
-                <a:solidFill>
-                  <a:srgbClr val="FFFFFF"/>
-                </a:solidFill>
-                <a:latin typeface="Microsoft YaHei"/>
-              </a:defRPr>
-            </a:pPr>
-            <a:r>
-              <a:t>阶段四: 数字孪生与 AI 决策支持</a:t>
-            </a:r>
-          </a:p>
-        </p:txBody>
-      </p:sp>
-      <p:sp>
-        <p:nvSpPr>
-          <p:cNvPr id="19" name="Rounded Rectangle 18"/>
-          <p:cNvSpPr/>
-          <p:nvPr/>
-        </p:nvSpPr>
-        <p:spPr>
-          <a:xfrm>
-            <a:off x="9070848" y="2057400"/>
-            <a:ext cx="2249424" cy="1112520"/>
-          </a:xfrm>
-          <a:prstGeom prst="roundRect">
             <a:avLst/>
           </a:prstGeom>
           <a:solidFill>
@@ -4019,7 +3885,7 @@
           </a:solidFill>
           <a:ln w="12700">
             <a:solidFill>
-              <a:srgbClr val="CBD5E1"/>
+              <a:srgbClr val="000000"/>
             </a:solidFill>
           </a:ln>
         </p:spPr>
@@ -4038,48 +3904,55 @@
           </a:fontRef>
         </p:style>
         <p:txBody>
-          <a:bodyPr rtlCol="0" anchor="ctr" wrap="square" tIns="73152" bIns="73152"/>
+          <a:bodyPr rtlCol="0" anchor="t" wrap="square" lIns="109728" rIns="109728" tIns="109728"/>
           <a:lstStyle/>
           <a:p>
             <a:pPr algn="ctr">
-              <a:defRPr sz="1100" b="1">
-                <a:solidFill>
-                  <a:srgbClr val="1A202C"/>
-                </a:solidFill>
-                <a:latin typeface="Microsoft YaHei"/>
+              <a:spcAft>
+                <a:spcPts val="400"/>
+              </a:spcAft>
+              <a:defRPr sz="1050" b="1">
+                <a:solidFill>
+                  <a:srgbClr val="000000"/>
+                </a:solidFill>
+                <a:latin typeface="Times New Roman"/>
               </a:defRPr>
             </a:pPr>
             <a:r>
-              <a:t>【第 7 章】GIS 与 GeoBIM 集成 (GeoBIM Integration)</a:t>
+              <a:t>第 7 章：GIS 与 GeoBIM 集成</a:t>
             </a:r>
           </a:p>
           <a:p>
             <a:pPr>
               <a:defRPr sz="950">
                 <a:solidFill>
-                  <a:srgbClr val="4A5568"/>
-                </a:solidFill>
-                <a:latin typeface="Microsoft YaHei"/>
+                  <a:srgbClr val="000000"/>
+                </a:solidFill>
+                <a:latin typeface="Times New Roman"/>
               </a:defRPr>
             </a:pPr>
             <a:r>
-              <a:t>空间数据库映射 • GeoBIM Schema • 资产护照挂载</a:t>
-            </a:r>
-          </a:p>
-        </p:txBody>
-      </p:sp>
-      <p:sp>
-        <p:nvSpPr>
-          <p:cNvPr id="20" name="Rounded Rectangle 19"/>
+              <a:t>• 空间数据库与 GeoBIM 映射</a:t>
+            </a:r>
+            <a:br/>
+            <a:r>
+              <a:t>• 缺陷与资产护照 (Passport) 挂载</a:t>
+            </a:r>
+          </a:p>
+        </p:txBody>
+      </p:sp>
+      <p:sp>
+        <p:nvSpPr>
+          <p:cNvPr id="16" name="Rectangle 15"/>
           <p:cNvSpPr/>
           <p:nvPr/>
         </p:nvSpPr>
         <p:spPr>
           <a:xfrm>
-            <a:off x="9070848" y="3261360"/>
-            <a:ext cx="2249424" cy="1112520"/>
-          </a:xfrm>
-          <a:prstGeom prst="roundRect">
+            <a:off x="9043416" y="3328416"/>
+            <a:ext cx="2423160" cy="1298448"/>
+          </a:xfrm>
+          <a:prstGeom prst="rect">
             <a:avLst/>
           </a:prstGeom>
           <a:solidFill>
@@ -4087,7 +3960,7 @@
           </a:solidFill>
           <a:ln w="12700">
             <a:solidFill>
-              <a:srgbClr val="CBD5E1"/>
+              <a:srgbClr val="000000"/>
             </a:solidFill>
           </a:ln>
         </p:spPr>
@@ -4106,48 +3979,55 @@
           </a:fontRef>
         </p:style>
         <p:txBody>
-          <a:bodyPr rtlCol="0" anchor="ctr" wrap="square" tIns="73152" bIns="73152"/>
+          <a:bodyPr rtlCol="0" anchor="t" wrap="square" lIns="109728" rIns="109728" tIns="109728"/>
           <a:lstStyle/>
           <a:p>
             <a:pPr algn="ctr">
-              <a:defRPr sz="1100" b="1">
-                <a:solidFill>
-                  <a:srgbClr val="1A202C"/>
-                </a:solidFill>
-                <a:latin typeface="Microsoft YaHei"/>
+              <a:spcAft>
+                <a:spcPts val="400"/>
+              </a:spcAft>
+              <a:defRPr sz="1050" b="1">
+                <a:solidFill>
+                  <a:srgbClr val="000000"/>
+                </a:solidFill>
+                <a:latin typeface="Times New Roman"/>
               </a:defRPr>
             </a:pPr>
             <a:r>
-              <a:t>【第 8 章】数字孪生与大模型 (DT &amp; LLM Reasoning)</a:t>
+              <a:t>第 8 章：数字孪生与大模型</a:t>
             </a:r>
           </a:p>
           <a:p>
             <a:pPr>
               <a:defRPr sz="950">
                 <a:solidFill>
-                  <a:srgbClr val="4A5568"/>
-                </a:solidFill>
-                <a:latin typeface="Microsoft YaHei"/>
+                  <a:srgbClr val="000000"/>
+                </a:solidFill>
+                <a:latin typeface="Times New Roman"/>
               </a:defRPr>
             </a:pPr>
             <a:r>
-              <a:t>LLM/VLM推理 • 检索增强生成(RAG) • 预测性维护决策</a:t>
-            </a:r>
-          </a:p>
-        </p:txBody>
-      </p:sp>
-      <p:sp>
-        <p:nvSpPr>
-          <p:cNvPr id="21" name="Rounded Rectangle 20"/>
+              <a:t>• LLM / VLM 检索增强推理 (RAG)</a:t>
+            </a:r>
+            <a:br/>
+            <a:r>
+              <a:t>• 历史维保查询与预测性维护</a:t>
+            </a:r>
+          </a:p>
+        </p:txBody>
+      </p:sp>
+      <p:sp>
+        <p:nvSpPr>
+          <p:cNvPr id="17" name="Rectangle 16"/>
           <p:cNvSpPr/>
           <p:nvPr/>
         </p:nvSpPr>
         <p:spPr>
           <a:xfrm>
-            <a:off x="9070848" y="4465320"/>
-            <a:ext cx="2249424" cy="1112520"/>
-          </a:xfrm>
-          <a:prstGeom prst="roundRect">
+            <a:off x="9043416" y="4736592"/>
+            <a:ext cx="2423160" cy="1298448"/>
+          </a:xfrm>
+          <a:prstGeom prst="rect">
             <a:avLst/>
           </a:prstGeom>
           <a:solidFill>
@@ -4155,7 +4035,7 @@
           </a:solidFill>
           <a:ln w="12700">
             <a:solidFill>
-              <a:srgbClr val="CBD5E1"/>
+              <a:srgbClr val="000000"/>
             </a:solidFill>
           </a:ln>
         </p:spPr>
@@ -4174,45 +4054,52 @@
           </a:fontRef>
         </p:style>
         <p:txBody>
-          <a:bodyPr rtlCol="0" anchor="ctr" wrap="square" tIns="73152" bIns="73152"/>
+          <a:bodyPr rtlCol="0" anchor="t" wrap="square" lIns="109728" rIns="109728" tIns="109728"/>
           <a:lstStyle/>
           <a:p>
             <a:pPr algn="ctr">
-              <a:defRPr sz="1100" b="1">
-                <a:solidFill>
-                  <a:srgbClr val="1A202C"/>
-                </a:solidFill>
-                <a:latin typeface="Microsoft YaHei"/>
+              <a:spcAft>
+                <a:spcPts val="400"/>
+              </a:spcAft>
+              <a:defRPr sz="1050" b="1">
+                <a:solidFill>
+                  <a:srgbClr val="000000"/>
+                </a:solidFill>
+                <a:latin typeface="Times New Roman"/>
               </a:defRPr>
             </a:pPr>
             <a:r>
-              <a:t>【第 9 章】总结与展望 (Conclusion &amp; Future)</a:t>
+              <a:t>第 9 章：总结与展望</a:t>
             </a:r>
           </a:p>
           <a:p>
             <a:pPr>
               <a:defRPr sz="950">
                 <a:solidFill>
-                  <a:srgbClr val="4A5568"/>
-                </a:solidFill>
-                <a:latin typeface="Microsoft YaHei"/>
+                  <a:srgbClr val="000000"/>
+                </a:solidFill>
+                <a:latin typeface="Times New Roman"/>
               </a:defRPr>
             </a:pPr>
             <a:r>
-              <a:t>现场部署经验审计 • 开放挑战与下一代智能运维展望</a:t>
-            </a:r>
-          </a:p>
-        </p:txBody>
-      </p:sp>
-      <p:sp>
-        <p:nvSpPr>
-          <p:cNvPr id="22" name="TextBox 21"/>
+              <a:t>• 现场部署经验审计</a:t>
+            </a:r>
+            <a:br/>
+            <a:r>
+              <a:t>• 开放挑战与下一代系统展望</a:t>
+            </a:r>
+          </a:p>
+        </p:txBody>
+      </p:sp>
+      <p:sp>
+        <p:nvSpPr>
+          <p:cNvPr id="18" name="TextBox 17"/>
           <p:cNvSpPr txBox="1"/>
           <p:nvPr/>
         </p:nvSpPr>
         <p:spPr>
           <a:xfrm>
-            <a:off x="731520" y="6172200"/>
+            <a:off x="731520" y="6217920"/>
             <a:ext cx="10728655" cy="365760"/>
           </a:xfrm>
           <a:prstGeom prst="rect">
@@ -4227,15 +4114,15 @@
           <a:lstStyle/>
           <a:p>
             <a:pPr>
-              <a:defRPr sz="1000" i="1">
-                <a:solidFill>
-                  <a:srgbClr val="4A5568"/>
-                </a:solidFill>
-                <a:latin typeface="Microsoft YaHei"/>
+              <a:defRPr sz="1000" b="1">
+                <a:solidFill>
+                  <a:srgbClr val="000000"/>
+                </a:solidFill>
+                <a:latin typeface="Times New Roman"/>
               </a:defRPr>
             </a:pPr>
             <a:r>
-              <a:t>注：从第2/3章自主飞行与采集，到第4/5章空间重建，第6章缺陷识别，最终至第7/8/9章数字孪生与大模型决策，形成完整的端到端智能运维闭环。</a:t>
+              <a:t>图 1.1：专著四阶段端到端技术路线与章节映射关系（从物理采集、三维重建到大模型决策支持）</a:t>
             </a:r>
           </a:p>
         </p:txBody>
@@ -4266,8 +4153,8 @@
         </p:nvSpPr>
         <p:spPr>
           <a:xfrm>
-            <a:off x="731520" y="365760"/>
-            <a:ext cx="10728655" cy="822960"/>
+            <a:off x="731520" y="411480"/>
+            <a:ext cx="10728655" cy="777240"/>
           </a:xfrm>
           <a:prstGeom prst="rect">
             <a:avLst/>
@@ -4275,7 +4162,7 @@
           <a:noFill/>
         </p:spPr>
         <p:txBody>
-          <a:bodyPr wrap="square">
+          <a:bodyPr wrap="square" lIns="0" tIns="0" rIns="0" bIns="0">
             <a:spAutoFit/>
           </a:bodyPr>
           <a:lstStyle/>
@@ -4283,761 +4170,26 @@
             <a:pPr>
               <a:defRPr sz="2200" b="1">
                 <a:solidFill>
-                  <a:srgbClr val="1A202C"/>
-                </a:solidFill>
-                <a:latin typeface="Arial"/>
+                  <a:srgbClr val="000000"/>
+                </a:solidFill>
+                <a:latin typeface="Times New Roman"/>
               </a:defRPr>
             </a:pPr>
             <a:r>
-              <a:t>全书章节数据流转与功能接口 (Data Flow &amp; Inter-Chapter Interfaces)</a:t>
+              <a:t>Overall Framework and Chapter Map</a:t>
             </a:r>
           </a:p>
           <a:p>
             <a:pPr>
               <a:defRPr sz="1200">
                 <a:solidFill>
-                  <a:srgbClr val="4A5568"/>
-                </a:solidFill>
-                <a:latin typeface="Microsoft YaHei"/>
+                  <a:srgbClr val="5A5A5A"/>
+                </a:solidFill>
+                <a:latin typeface="Times New Roman"/>
               </a:defRPr>
             </a:pPr>
             <a:r>
-              <a:t>构建从底层物理采样到高层大模型推理的完整数据链条 (Data Chain from Physical Sensing to Cognitive LLM)</a:t>
-            </a:r>
-          </a:p>
-        </p:txBody>
-      </p:sp>
-      <p:graphicFrame>
-        <p:nvGraphicFramePr>
-          <p:cNvPr id="3" name="Table 2"/>
-          <p:cNvGraphicFramePr>
-            <a:graphicFrameLocks noGrp="1"/>
-          </p:cNvGraphicFramePr>
-          <p:nvPr/>
-        </p:nvGraphicFramePr>
-        <p:xfrm>
-          <a:off x="731520" y="1371600"/>
-          <a:ext cx="10728655" cy="4754880"/>
-        </p:xfrm>
-        <a:graphic>
-          <a:graphicData uri="http://schemas.openxmlformats.org/drawingml/2006/table">
-            <a:tbl>
-              <a:tblPr firstRow="1" bandRow="1">
-                <a:tableStyleId>{5C22544A-7EE6-4342-B048-85BDC9FD1C3A}</a:tableStyleId>
-              </a:tblPr>
-              <a:tblGrid>
-                <a:gridCol w="2011680"/>
-                <a:gridCol w="2560320"/>
-                <a:gridCol w="3566160"/>
-                <a:gridCol w="2590495"/>
-              </a:tblGrid>
-              <a:tr h="792480">
-                <a:tc>
-                  <a:txBody>
-                    <a:bodyPr/>
-                    <a:lstStyle/>
-                    <a:p>
-                      <a:pPr algn="ctr">
-                        <a:defRPr sz="1100" b="1">
-                          <a:solidFill>
-                            <a:srgbClr val="1A202C"/>
-                          </a:solidFill>
-                          <a:latin typeface="Microsoft YaHei"/>
-                        </a:defRPr>
-                      </a:pPr>
-                      <a:r>
-                        <a:t>阶段 / 章节 (Phase &amp; Chapter)</a:t>
-                      </a:r>
-                    </a:p>
-                  </a:txBody>
-                  <a:tcPr>
-                    <a:solidFill>
-                      <a:srgbClr val="E2E8F0"/>
-                    </a:solidFill>
-                  </a:tcPr>
-                </a:tc>
-                <a:tc>
-                  <a:txBody>
-                    <a:bodyPr/>
-                    <a:lstStyle/>
-                    <a:p>
-                      <a:pPr algn="ctr">
-                        <a:defRPr sz="1100" b="1">
-                          <a:solidFill>
-                            <a:srgbClr val="1A202C"/>
-                          </a:solidFill>
-                          <a:latin typeface="Microsoft YaHei"/>
-                        </a:defRPr>
-                      </a:pPr>
-                      <a:r>
-                        <a:t>输出数据/资产 (Data &amp; Asset)</a:t>
-                      </a:r>
-                    </a:p>
-                  </a:txBody>
-                  <a:tcPr>
-                    <a:solidFill>
-                      <a:srgbClr val="E2E8F0"/>
-                    </a:solidFill>
-                  </a:tcPr>
-                </a:tc>
-                <a:tc>
-                  <a:txBody>
-                    <a:bodyPr/>
-                    <a:lstStyle/>
-                    <a:p>
-                      <a:pPr algn="ctr">
-                        <a:defRPr sz="1100" b="1">
-                          <a:solidFill>
-                            <a:srgbClr val="1A202C"/>
-                          </a:solidFill>
-                          <a:latin typeface="Microsoft YaHei"/>
-                        </a:defRPr>
-                      </a:pPr>
-                      <a:r>
-                        <a:t>核心处理/功能 (Key Operation)</a:t>
-                      </a:r>
-                    </a:p>
-                  </a:txBody>
-                  <a:tcPr>
-                    <a:solidFill>
-                      <a:srgbClr val="E2E8F0"/>
-                    </a:solidFill>
-                  </a:tcPr>
-                </a:tc>
-                <a:tc>
-                  <a:txBody>
-                    <a:bodyPr/>
-                    <a:lstStyle/>
-                    <a:p>
-                      <a:pPr algn="ctr">
-                        <a:defRPr sz="1100" b="1">
-                          <a:solidFill>
-                            <a:srgbClr val="1A202C"/>
-                          </a:solidFill>
-                          <a:latin typeface="Microsoft YaHei"/>
-                        </a:defRPr>
-                      </a:pPr>
-                      <a:r>
-                        <a:t>下游对接章节 (Target Chapter)</a:t>
-                      </a:r>
-                    </a:p>
-                  </a:txBody>
-                  <a:tcPr>
-                    <a:solidFill>
-                      <a:srgbClr val="E2E8F0"/>
-                    </a:solidFill>
-                  </a:tcPr>
-                </a:tc>
-              </a:tr>
-              <a:tr h="792480">
-                <a:tc>
-                  <a:txBody>
-                    <a:bodyPr/>
-                    <a:lstStyle/>
-                    <a:p>
-                      <a:pPr>
-                        <a:defRPr sz="1000">
-                          <a:solidFill>
-                            <a:srgbClr val="1A202C"/>
-                          </a:solidFill>
-                          <a:latin typeface="Microsoft YaHei"/>
-                        </a:defRPr>
-                      </a:pPr>
-                      <a:r>
-                        <a:t>第 2 &amp; 3 章: 任务与运动规划</a:t>
-                      </a:r>
-                      <a:br/>
-                      <a:r>
-                        <a:t>(Flight &amp; Motion Planning)</a:t>
-                      </a:r>
-                    </a:p>
-                  </a:txBody>
-                  <a:tcPr>
-                    <a:solidFill>
-                      <a:srgbClr val="FFFFFF"/>
-                    </a:solidFill>
-                  </a:tcPr>
-                </a:tc>
-                <a:tc>
-                  <a:txBody>
-                    <a:bodyPr/>
-                    <a:lstStyle/>
-                    <a:p>
-                      <a:pPr>
-                        <a:defRPr sz="1000">
-                          <a:solidFill>
-                            <a:srgbClr val="1A202C"/>
-                          </a:solidFill>
-                          <a:latin typeface="Microsoft YaHei"/>
-                        </a:defRPr>
-                      </a:pPr>
-                      <a:r>
-                        <a:t>三维无碰撞巡检轨迹</a:t>
-                      </a:r>
-                      <a:br/>
-                      <a:r>
-                        <a:t>多模态影像数据集 (RGB/Thermal)</a:t>
-                      </a:r>
-                    </a:p>
-                  </a:txBody>
-                  <a:tcPr>
-                    <a:solidFill>
-                      <a:srgbClr val="FFFFFF"/>
-                    </a:solidFill>
-                  </a:tcPr>
-                </a:tc>
-                <a:tc>
-                  <a:txBody>
-                    <a:bodyPr/>
-                    <a:lstStyle/>
-                    <a:p>
-                      <a:pPr>
-                        <a:defRPr sz="1000">
-                          <a:solidFill>
-                            <a:srgbClr val="1A202C"/>
-                          </a:solidFill>
-                          <a:latin typeface="Microsoft YaHei"/>
-                        </a:defRPr>
-                      </a:pPr>
-                      <a:r>
-                        <a:t>覆盖率优化路径生成、实时避障与风场扰动控制</a:t>
-                      </a:r>
-                    </a:p>
-                  </a:txBody>
-                  <a:tcPr>
-                    <a:solidFill>
-                      <a:srgbClr val="FFFFFF"/>
-                    </a:solidFill>
-                  </a:tcPr>
-                </a:tc>
-                <a:tc>
-                  <a:txBody>
-                    <a:bodyPr/>
-                    <a:lstStyle/>
-                    <a:p>
-                      <a:pPr>
-                        <a:defRPr sz="1000">
-                          <a:solidFill>
-                            <a:srgbClr val="1A202C"/>
-                          </a:solidFill>
-                          <a:latin typeface="Microsoft YaHei"/>
-                        </a:defRPr>
-                      </a:pPr>
-                      <a:r>
-                        <a:t>第 4 &amp; 5 章: 重建与数据集</a:t>
-                      </a:r>
-                    </a:p>
-                  </a:txBody>
-                  <a:tcPr>
-                    <a:solidFill>
-                      <a:srgbClr val="FFFFFF"/>
-                    </a:solidFill>
-                  </a:tcPr>
-                </a:tc>
-              </a:tr>
-              <a:tr h="792480">
-                <a:tc>
-                  <a:txBody>
-                    <a:bodyPr/>
-                    <a:lstStyle/>
-                    <a:p>
-                      <a:pPr>
-                        <a:defRPr sz="1000">
-                          <a:solidFill>
-                            <a:srgbClr val="1A202C"/>
-                          </a:solidFill>
-                          <a:latin typeface="Microsoft YaHei"/>
-                        </a:defRPr>
-                      </a:pPr>
-                      <a:r>
-                        <a:t>第 4 &amp; 5 章: 3D重建与数据集</a:t>
-                      </a:r>
-                      <a:br/>
-                      <a:r>
-                        <a:t>(Reconstruction &amp; Datasets)</a:t>
-                      </a:r>
-                    </a:p>
-                  </a:txBody>
-                  <a:tcPr>
-                    <a:solidFill>
-                      <a:srgbClr val="F8FAFC"/>
-                    </a:solidFill>
-                  </a:tcPr>
-                </a:tc>
-                <a:tc>
-                  <a:txBody>
-                    <a:bodyPr/>
-                    <a:lstStyle/>
-                    <a:p>
-                      <a:pPr>
-                        <a:defRPr sz="1000">
-                          <a:solidFill>
-                            <a:srgbClr val="1A202C"/>
-                          </a:solidFill>
-                          <a:latin typeface="Microsoft YaHei"/>
-                        </a:defRPr>
-                      </a:pPr>
-                      <a:r>
-                        <a:t>高精度点云、网格模型(Mesh)</a:t>
-                      </a:r>
-                      <a:br/>
-                      <a:r>
-                        <a:t>标注对齐的缺陷图像集</a:t>
-                      </a:r>
-                    </a:p>
-                  </a:txBody>
-                  <a:tcPr>
-                    <a:solidFill>
-                      <a:srgbClr val="F8FAFC"/>
-                    </a:solidFill>
-                  </a:tcPr>
-                </a:tc>
-                <a:tc>
-                  <a:txBody>
-                    <a:bodyPr/>
-                    <a:lstStyle/>
-                    <a:p>
-                      <a:pPr>
-                        <a:defRPr sz="1000">
-                          <a:solidFill>
-                            <a:srgbClr val="1A202C"/>
-                          </a:solidFill>
-                          <a:latin typeface="Microsoft YaHei"/>
-                        </a:defRPr>
-                      </a:pPr>
-                      <a:r>
-                        <a:t>倾斜摄影测量、BIM坐标系精准对齐、标定与分割</a:t>
-                      </a:r>
-                    </a:p>
-                  </a:txBody>
-                  <a:tcPr>
-                    <a:solidFill>
-                      <a:srgbClr val="F8FAFC"/>
-                    </a:solidFill>
-                  </a:tcPr>
-                </a:tc>
-                <a:tc>
-                  <a:txBody>
-                    <a:bodyPr/>
-                    <a:lstStyle/>
-                    <a:p>
-                      <a:pPr>
-                        <a:defRPr sz="1000">
-                          <a:solidFill>
-                            <a:srgbClr val="1A202C"/>
-                          </a:solidFill>
-                          <a:latin typeface="Microsoft YaHei"/>
-                        </a:defRPr>
-                      </a:pPr>
-                      <a:r>
-                        <a:t>第 6 章: AI缺陷检测</a:t>
-                      </a:r>
-                      <a:br/>
-                      <a:r>
-                        <a:t>第 7 章: GIS/GeoBIM</a:t>
-                      </a:r>
-                    </a:p>
-                  </a:txBody>
-                  <a:tcPr>
-                    <a:solidFill>
-                      <a:srgbClr val="F8FAFC"/>
-                    </a:solidFill>
-                  </a:tcPr>
-                </a:tc>
-              </a:tr>
-              <a:tr h="792480">
-                <a:tc>
-                  <a:txBody>
-                    <a:bodyPr/>
-                    <a:lstStyle/>
-                    <a:p>
-                      <a:pPr>
-                        <a:defRPr sz="1000">
-                          <a:solidFill>
-                            <a:srgbClr val="1A202C"/>
-                          </a:solidFill>
-                          <a:latin typeface="Microsoft YaHei"/>
-                        </a:defRPr>
-                      </a:pPr>
-                      <a:r>
-                        <a:t>第 6 章: 缺陷检测 AI 模型</a:t>
-                      </a:r>
-                      <a:br/>
-                      <a:r>
-                        <a:t>(AI Defect Perception)</a:t>
-                      </a:r>
-                    </a:p>
-                  </a:txBody>
-                  <a:tcPr>
-                    <a:solidFill>
-                      <a:srgbClr val="FFFFFF"/>
-                    </a:solidFill>
-                  </a:tcPr>
-                </a:tc>
-                <a:tc>
-                  <a:txBody>
-                    <a:bodyPr/>
-                    <a:lstStyle/>
-                    <a:p>
-                      <a:pPr>
-                        <a:defRPr sz="1000">
-                          <a:solidFill>
-                            <a:srgbClr val="1A202C"/>
-                          </a:solidFill>
-                          <a:latin typeface="Microsoft YaHei"/>
-                        </a:defRPr>
-                      </a:pPr>
-                      <a:r>
-                        <a:t>缺陷 bounding boxes/掩码</a:t>
-                      </a:r>
-                      <a:br/>
-                      <a:r>
-                        <a:t>构件级缺陷类型、面积与定量指标</a:t>
-                      </a:r>
-                    </a:p>
-                  </a:txBody>
-                  <a:tcPr>
-                    <a:solidFill>
-                      <a:srgbClr val="FFFFFF"/>
-                    </a:solidFill>
-                  </a:tcPr>
-                </a:tc>
-                <a:tc>
-                  <a:txBody>
-                    <a:bodyPr/>
-                    <a:lstStyle/>
-                    <a:p>
-                      <a:pPr>
-                        <a:defRPr sz="1000">
-                          <a:solidFill>
-                            <a:srgbClr val="1A202C"/>
-                          </a:solidFill>
-                          <a:latin typeface="Microsoft YaHei"/>
-                        </a:defRPr>
-                      </a:pPr>
-                      <a:r>
-                        <a:t>深度学习目标检测、实例分割、缺陷严重程度量化</a:t>
-                      </a:r>
-                    </a:p>
-                  </a:txBody>
-                  <a:tcPr>
-                    <a:solidFill>
-                      <a:srgbClr val="FFFFFF"/>
-                    </a:solidFill>
-                  </a:tcPr>
-                </a:tc>
-                <a:tc>
-                  <a:txBody>
-                    <a:bodyPr/>
-                    <a:lstStyle/>
-                    <a:p>
-                      <a:pPr>
-                        <a:defRPr sz="1000">
-                          <a:solidFill>
-                            <a:srgbClr val="1A202C"/>
-                          </a:solidFill>
-                          <a:latin typeface="Microsoft YaHei"/>
-                        </a:defRPr>
-                      </a:pPr>
-                      <a:r>
-                        <a:t>第 7 章: GeoBIM 挂载</a:t>
-                      </a:r>
-                      <a:br/>
-                      <a:r>
-                        <a:t>第 8 章: 数字孪生推理</a:t>
-                      </a:r>
-                    </a:p>
-                  </a:txBody>
-                  <a:tcPr>
-                    <a:solidFill>
-                      <a:srgbClr val="FFFFFF"/>
-                    </a:solidFill>
-                  </a:tcPr>
-                </a:tc>
-              </a:tr>
-              <a:tr h="792480">
-                <a:tc>
-                  <a:txBody>
-                    <a:bodyPr/>
-                    <a:lstStyle/>
-                    <a:p>
-                      <a:pPr>
-                        <a:defRPr sz="1000">
-                          <a:solidFill>
-                            <a:srgbClr val="1A202C"/>
-                          </a:solidFill>
-                          <a:latin typeface="Microsoft YaHei"/>
-                        </a:defRPr>
-                      </a:pPr>
-                      <a:r>
-                        <a:t>第 7 章: GIS 与 GeoBIM 集成</a:t>
-                      </a:r>
-                      <a:br/>
-                      <a:r>
-                        <a:t>(GeoBIM &amp; Asset Passports)</a:t>
-                      </a:r>
-                    </a:p>
-                  </a:txBody>
-                  <a:tcPr>
-                    <a:solidFill>
-                      <a:srgbClr val="F8FAFC"/>
-                    </a:solidFill>
-                  </a:tcPr>
-                </a:tc>
-                <a:tc>
-                  <a:txBody>
-                    <a:bodyPr/>
-                    <a:lstStyle/>
-                    <a:p>
-                      <a:pPr>
-                        <a:defRPr sz="1000">
-                          <a:solidFill>
-                            <a:srgbClr val="1A202C"/>
-                          </a:solidFill>
-                          <a:latin typeface="Microsoft YaHei"/>
-                        </a:defRPr>
-                      </a:pPr>
-                      <a:r>
-                        <a:t>挂载缺陷的 GeoBIM 资产护照</a:t>
-                      </a:r>
-                      <a:br/>
-                      <a:r>
-                        <a:t>空间拓扑关系数据库 (Spatial Graph)</a:t>
-                      </a:r>
-                    </a:p>
-                  </a:txBody>
-                  <a:tcPr>
-                    <a:solidFill>
-                      <a:srgbClr val="F8FAFC"/>
-                    </a:solidFill>
-                  </a:tcPr>
-                </a:tc>
-                <a:tc>
-                  <a:txBody>
-                    <a:bodyPr/>
-                    <a:lstStyle/>
-                    <a:p>
-                      <a:pPr>
-                        <a:defRPr sz="1000">
-                          <a:solidFill>
-                            <a:srgbClr val="1A202C"/>
-                          </a:solidFill>
-                          <a:latin typeface="Microsoft YaHei"/>
-                        </a:defRPr>
-                      </a:pPr>
-                      <a:r>
-                        <a:t>空间关联分析、Asset-ID 语义绑定、历史维保数据库归档</a:t>
-                      </a:r>
-                    </a:p>
-                  </a:txBody>
-                  <a:tcPr>
-                    <a:solidFill>
-                      <a:srgbClr val="F8FAFC"/>
-                    </a:solidFill>
-                  </a:tcPr>
-                </a:tc>
-                <a:tc>
-                  <a:txBody>
-                    <a:bodyPr/>
-                    <a:lstStyle/>
-                    <a:p>
-                      <a:pPr>
-                        <a:defRPr sz="1000">
-                          <a:solidFill>
-                            <a:srgbClr val="1A202C"/>
-                          </a:solidFill>
-                          <a:latin typeface="Microsoft YaHei"/>
-                        </a:defRPr>
-                      </a:pPr>
-                      <a:r>
-                        <a:t>第 8 章: 大模型决策支持</a:t>
-                      </a:r>
-                    </a:p>
-                  </a:txBody>
-                  <a:tcPr>
-                    <a:solidFill>
-                      <a:srgbClr val="F8FAFC"/>
-                    </a:solidFill>
-                  </a:tcPr>
-                </a:tc>
-              </a:tr>
-              <a:tr h="792480">
-                <a:tc>
-                  <a:txBody>
-                    <a:bodyPr/>
-                    <a:lstStyle/>
-                    <a:p>
-                      <a:pPr>
-                        <a:defRPr sz="1000">
-                          <a:solidFill>
-                            <a:srgbClr val="1A202C"/>
-                          </a:solidFill>
-                          <a:latin typeface="Microsoft YaHei"/>
-                        </a:defRPr>
-                      </a:pPr>
-                      <a:r>
-                        <a:t>第 8 &amp; 9 章: 数字孪生与大模型</a:t>
-                      </a:r>
-                      <a:br/>
-                      <a:r>
-                        <a:t>(DT &amp; LLM Decision Support)</a:t>
-                      </a:r>
-                    </a:p>
-                  </a:txBody>
-                  <a:tcPr>
-                    <a:solidFill>
-                      <a:srgbClr val="FFFFFF"/>
-                    </a:solidFill>
-                  </a:tcPr>
-                </a:tc>
-                <a:tc>
-                  <a:txBody>
-                    <a:bodyPr/>
-                    <a:lstStyle/>
-                    <a:p>
-                      <a:pPr>
-                        <a:defRPr sz="1000">
-                          <a:solidFill>
-                            <a:srgbClr val="1A202C"/>
-                          </a:solidFill>
-                          <a:latin typeface="Microsoft YaHei"/>
-                        </a:defRPr>
-                      </a:pPr>
-                      <a:r>
-                        <a:t>可审计巡检报告、维保建议工单</a:t>
-                      </a:r>
-                      <a:br/>
-                      <a:r>
-                        <a:t>闭环复巡指令 (Re-inspection Task)</a:t>
-                      </a:r>
-                    </a:p>
-                  </a:txBody>
-                  <a:tcPr>
-                    <a:solidFill>
-                      <a:srgbClr val="FFFFFF"/>
-                    </a:solidFill>
-                  </a:tcPr>
-                </a:tc>
-                <a:tc>
-                  <a:txBody>
-                    <a:bodyPr/>
-                    <a:lstStyle/>
-                    <a:p>
-                      <a:pPr>
-                        <a:defRPr sz="1000">
-                          <a:solidFill>
-                            <a:srgbClr val="1A202C"/>
-                          </a:solidFill>
-                          <a:latin typeface="Microsoft YaHei"/>
-                        </a:defRPr>
-                      </a:pPr>
-                      <a:r>
-                        <a:t>检索增强生成 (RAG)、历史记录查询、预测性维护决策</a:t>
-                      </a:r>
-                    </a:p>
-                  </a:txBody>
-                  <a:tcPr>
-                    <a:solidFill>
-                      <a:srgbClr val="FFFFFF"/>
-                    </a:solidFill>
-                  </a:tcPr>
-                </a:tc>
-                <a:tc>
-                  <a:txBody>
-                    <a:bodyPr/>
-                    <a:lstStyle/>
-                    <a:p>
-                      <a:pPr>
-                        <a:defRPr sz="1000">
-                          <a:solidFill>
-                            <a:srgbClr val="1A202C"/>
-                          </a:solidFill>
-                          <a:latin typeface="Microsoft YaHei"/>
-                        </a:defRPr>
-                      </a:pPr>
-                      <a:r>
-                        <a:t>反馈至 第 2 章 闭环复巡</a:t>
-                      </a:r>
-                      <a:br/>
-                      <a:r>
-                        <a:t>及现场运维工程应用</a:t>
-                      </a:r>
-                    </a:p>
-                  </a:txBody>
-                  <a:tcPr>
-                    <a:solidFill>
-                      <a:srgbClr val="FFFFFF"/>
-                    </a:solidFill>
-                  </a:tcPr>
-                </a:tc>
-              </a:tr>
-            </a:tbl>
-          </a:graphicData>
-        </a:graphic>
-      </p:graphicFrame>
-    </p:spTree>
-  </p:cSld>
-  <p:clrMapOvr>
-    <a:masterClrMapping/>
-  </p:clrMapOvr>
-</p:sld>
-</file>
-
-<file path=ppt/slides/slide3.xml><?xml version="1.0" encoding="utf-8"?>
-<p:sld xmlns:a="http://schemas.openxmlformats.org/drawingml/2006/main" xmlns:p="http://schemas.openxmlformats.org/presentationml/2006/main" xmlns:r="http://schemas.openxmlformats.org/officeDocument/2006/relationships">
-  <p:cSld>
-    <p:spTree>
-      <p:nvGrpSpPr>
-        <p:cNvPr id="1" name=""/>
-        <p:cNvGrpSpPr/>
-        <p:nvPr/>
-      </p:nvGrpSpPr>
-      <p:grpSpPr/>
-      <p:sp>
-        <p:nvSpPr>
-          <p:cNvPr id="2" name="TextBox 1"/>
-          <p:cNvSpPr txBox="1"/>
-          <p:nvPr/>
-        </p:nvSpPr>
-        <p:spPr>
-          <a:xfrm>
-            <a:off x="731520" y="365760"/>
-            <a:ext cx="10728655" cy="822960"/>
-          </a:xfrm>
-          <a:prstGeom prst="rect">
-            <a:avLst/>
-          </a:prstGeom>
-          <a:noFill/>
-        </p:spPr>
-        <p:txBody>
-          <a:bodyPr wrap="square">
-            <a:spAutoFit/>
-          </a:bodyPr>
-          <a:lstStyle/>
-          <a:p>
-            <a:pPr>
-              <a:defRPr sz="2200" b="1">
-                <a:solidFill>
-                  <a:srgbClr val="1A202C"/>
-                </a:solidFill>
-                <a:latin typeface="Arial"/>
-              </a:defRPr>
-            </a:pPr>
-            <a:r>
-              <a:t>建筑巡检端到端四层系统架构视图 (Four-Layer System Architecture)</a:t>
-            </a:r>
-          </a:p>
-          <a:p>
-            <a:pPr>
-              <a:defRPr sz="1200">
-                <a:solidFill>
-                  <a:srgbClr val="4A5568"/>
-                </a:solidFill>
-                <a:latin typeface="Microsoft YaHei"/>
-              </a:defRPr>
-            </a:pPr>
-            <a:r>
-              <a:t>物理域、空间域、感知域与认知域的解耦与协同 (Decoupled Co-Design from Flight to Cognitive Reasoning)</a:t>
+              <a:t>AI-Driven UAV Building Inspection: An End-to-End Framework from Autonomous Flight to Digital Twins</a:t>
             </a:r>
           </a:p>
         </p:txBody>
@@ -5051,17 +4203,17 @@
         <p:spPr>
           <a:xfrm>
             <a:off x="731520" y="1371600"/>
-            <a:ext cx="10728655" cy="1051560"/>
+            <a:ext cx="2423160" cy="457200"/>
           </a:xfrm>
           <a:prstGeom prst="rect">
             <a:avLst/>
           </a:prstGeom>
           <a:solidFill>
-            <a:srgbClr val="F1F5F9"/>
+            <a:srgbClr val="FFFFFF"/>
           </a:solidFill>
-          <a:ln w="19050">
+          <a:ln w="15875">
             <a:solidFill>
-              <a:srgbClr val="475569"/>
+              <a:srgbClr val="000000"/>
             </a:solidFill>
           </a:ln>
         </p:spPr>
@@ -5080,55 +4232,44 @@
           </a:fontRef>
         </p:style>
         <p:txBody>
-          <a:bodyPr rtlCol="0" anchor="ctr" wrap="square" lIns="182880" rIns="182880" tIns="91440" bIns="91440"/>
+          <a:bodyPr rtlCol="0" anchor="ctr"/>
           <a:lstStyle/>
           <a:p>
             <a:pPr algn="ctr">
-              <a:defRPr sz="1200" b="1">
-                <a:solidFill>
-                  <a:srgbClr val="1A202C"/>
-                </a:solidFill>
-                <a:latin typeface="Microsoft YaHei"/>
+              <a:defRPr sz="1100" b="1">
+                <a:solidFill>
+                  <a:srgbClr val="000000"/>
+                </a:solidFill>
+                <a:latin typeface="Times New Roman"/>
               </a:defRPr>
             </a:pPr>
             <a:r>
-              <a:t>L4: 认知与决策层 (Cognitive &amp; Decision Domain)   │   对应章节: 第 8 章 (DT + LLM) &amp; 第 9 章 (总结与展望)</a:t>
-            </a:r>
-          </a:p>
-          <a:p>
-            <a:pPr>
-              <a:defRPr sz="1050">
-                <a:solidFill>
-                  <a:srgbClr val="4A5568"/>
-                </a:solidFill>
-                <a:latin typeface="Microsoft YaHei"/>
-              </a:defRPr>
-            </a:pPr>
-            <a:r>
-              <a:t>核心功能组件: 即用型大语言模型 (LLM/VLM) • 检索增强生成 (RAG) • 历史维修记录查询 • 预测性维护决策 • 报告自动生成与工单下发</a:t>
-            </a:r>
-          </a:p>
-        </p:txBody>
-      </p:sp>
-      <p:sp>
-        <p:nvSpPr>
-          <p:cNvPr id="4" name="Down Arrow 3"/>
+              <a:t>Phase I: Flight &amp; Acquisition</a:t>
+            </a:r>
+          </a:p>
+        </p:txBody>
+      </p:sp>
+      <p:sp>
+        <p:nvSpPr>
+          <p:cNvPr id="4" name="Rectangle 3"/>
           <p:cNvSpPr/>
           <p:nvPr/>
         </p:nvSpPr>
         <p:spPr>
           <a:xfrm>
-            <a:off x="5852160" y="2441448"/>
-            <a:ext cx="228600" cy="100584"/>
-          </a:xfrm>
-          <a:prstGeom prst="downArrow">
+            <a:off x="731520" y="1920240"/>
+            <a:ext cx="2423160" cy="2002536"/>
+          </a:xfrm>
+          <a:prstGeom prst="rect">
             <a:avLst/>
           </a:prstGeom>
           <a:solidFill>
-            <a:srgbClr val="4A5568"/>
+            <a:srgbClr val="FFFFFF"/>
           </a:solidFill>
-          <a:ln>
-            <a:noFill/>
+          <a:ln w="12700">
+            <a:solidFill>
+              <a:srgbClr val="000000"/>
+            </a:solidFill>
           </a:ln>
         </p:spPr>
         <p:style>
@@ -5146,10 +4287,40 @@
           </a:fontRef>
         </p:style>
         <p:txBody>
-          <a:bodyPr rtlCol="0" anchor="ctr"/>
-          <a:lstStyle/>
-          <a:p>
-            <a:pPr algn="ctr"/>
+          <a:bodyPr rtlCol="0" anchor="t" wrap="square" lIns="109728" rIns="109728" tIns="109728"/>
+          <a:lstStyle/>
+          <a:p>
+            <a:pPr algn="ctr">
+              <a:spcAft>
+                <a:spcPts val="400"/>
+              </a:spcAft>
+              <a:defRPr sz="1050" b="1">
+                <a:solidFill>
+                  <a:srgbClr val="000000"/>
+                </a:solidFill>
+                <a:latin typeface="Times New Roman"/>
+              </a:defRPr>
+            </a:pPr>
+            <a:r>
+              <a:t>Chapter 2: Task Planning</a:t>
+            </a:r>
+          </a:p>
+          <a:p>
+            <a:pPr>
+              <a:defRPr sz="950">
+                <a:solidFill>
+                  <a:srgbClr val="000000"/>
+                </a:solidFill>
+                <a:latin typeface="Times New Roman"/>
+              </a:defRPr>
+            </a:pPr>
+            <a:r>
+              <a:t>• Façade inspection path planning</a:t>
+            </a:r>
+            <a:br/>
+            <a:r>
+              <a:t>• ROI definition &amp; multi-UAV routing</a:t>
+            </a:r>
           </a:p>
         </p:txBody>
       </p:sp>
@@ -5161,18 +4332,18 @@
         </p:nvSpPr>
         <p:spPr>
           <a:xfrm>
-            <a:off x="731520" y="2560320"/>
-            <a:ext cx="10728655" cy="1051560"/>
+            <a:off x="731520" y="4032504"/>
+            <a:ext cx="2423160" cy="2002536"/>
           </a:xfrm>
           <a:prstGeom prst="rect">
             <a:avLst/>
           </a:prstGeom>
           <a:solidFill>
-            <a:srgbClr val="F8FAFC"/>
+            <a:srgbClr val="FFFFFF"/>
           </a:solidFill>
-          <a:ln w="19050">
+          <a:ln w="12700">
             <a:solidFill>
-              <a:srgbClr val="94A3B8"/>
+              <a:srgbClr val="000000"/>
             </a:solidFill>
           </a:ln>
         </p:spPr>
@@ -5191,52 +4362,59 @@
           </a:fontRef>
         </p:style>
         <p:txBody>
-          <a:bodyPr rtlCol="0" anchor="ctr" wrap="square" lIns="182880" rIns="182880" tIns="91440" bIns="91440"/>
+          <a:bodyPr rtlCol="0" anchor="t" wrap="square" lIns="109728" rIns="109728" tIns="109728"/>
           <a:lstStyle/>
           <a:p>
             <a:pPr algn="ctr">
-              <a:defRPr sz="1200" b="1">
-                <a:solidFill>
-                  <a:srgbClr val="1A202C"/>
-                </a:solidFill>
-                <a:latin typeface="Microsoft YaHei"/>
+              <a:spcAft>
+                <a:spcPts val="400"/>
+              </a:spcAft>
+              <a:defRPr sz="1050" b="1">
+                <a:solidFill>
+                  <a:srgbClr val="000000"/>
+                </a:solidFill>
+                <a:latin typeface="Times New Roman"/>
               </a:defRPr>
             </a:pPr>
             <a:r>
-              <a:t>L3: 感知与资产层 (Perception &amp; Asset Management Domain)   │   对应章节: 第 6 章 (AI检测模型) &amp; 第 7 章 (GIS &amp; GeoBIM集成)</a:t>
+              <a:t>Chapter 3: Motion Planning</a:t>
             </a:r>
           </a:p>
           <a:p>
             <a:pPr>
-              <a:defRPr sz="1050">
-                <a:solidFill>
-                  <a:srgbClr val="4A5568"/>
-                </a:solidFill>
-                <a:latin typeface="Microsoft YaHei"/>
+              <a:defRPr sz="950">
+                <a:solidFill>
+                  <a:srgbClr val="000000"/>
+                </a:solidFill>
+                <a:latin typeface="Times New Roman"/>
               </a:defRPr>
             </a:pPr>
             <a:r>
-              <a:t>核心功能组件: 深度学习缺陷检测/实例分割 • 图像语义分析 • GeoBIM 空间数据库 • 资产护照 (Asset Passport) • 拓扑关系链锚定</a:t>
-            </a:r>
-          </a:p>
-        </p:txBody>
-      </p:sp>
-      <p:sp>
-        <p:nvSpPr>
-          <p:cNvPr id="6" name="Down Arrow 5"/>
+              <a:t>• Obstacle avoidance &amp; trajectory opt.</a:t>
+            </a:r>
+            <a:br/>
+            <a:r>
+              <a:t>• Wind disturbance adaptation</a:t>
+            </a:r>
+          </a:p>
+        </p:txBody>
+      </p:sp>
+      <p:sp>
+        <p:nvSpPr>
+          <p:cNvPr id="6" name="Right Arrow 5"/>
           <p:cNvSpPr/>
           <p:nvPr/>
         </p:nvSpPr>
         <p:spPr>
           <a:xfrm>
-            <a:off x="5852160" y="3630168"/>
-            <a:ext cx="228600" cy="100584"/>
-          </a:xfrm>
-          <a:prstGeom prst="downArrow">
+            <a:off x="3227832" y="3593592"/>
+            <a:ext cx="201168" cy="219456"/>
+          </a:xfrm>
+          <a:prstGeom prst="rightArrow">
             <a:avLst/>
           </a:prstGeom>
           <a:solidFill>
-            <a:srgbClr val="4A5568"/>
+            <a:srgbClr val="000000"/>
           </a:solidFill>
           <a:ln>
             <a:noFill/>
@@ -5272,18 +4450,18 @@
         </p:nvSpPr>
         <p:spPr>
           <a:xfrm>
-            <a:off x="731520" y="3749040"/>
-            <a:ext cx="10728655" cy="1051560"/>
+            <a:off x="3502152" y="1371600"/>
+            <a:ext cx="2423160" cy="457200"/>
           </a:xfrm>
           <a:prstGeom prst="rect">
             <a:avLst/>
           </a:prstGeom>
           <a:solidFill>
-            <a:srgbClr val="F8FAFC"/>
+            <a:srgbClr val="FFFFFF"/>
           </a:solidFill>
-          <a:ln w="19050">
+          <a:ln w="15875">
             <a:solidFill>
-              <a:srgbClr val="94A3B8"/>
+              <a:srgbClr val="000000"/>
             </a:solidFill>
           </a:ln>
         </p:spPr>
@@ -5302,55 +4480,44 @@
           </a:fontRef>
         </p:style>
         <p:txBody>
-          <a:bodyPr rtlCol="0" anchor="ctr" wrap="square" lIns="182880" rIns="182880" tIns="91440" bIns="91440"/>
+          <a:bodyPr rtlCol="0" anchor="ctr"/>
           <a:lstStyle/>
           <a:p>
             <a:pPr algn="ctr">
-              <a:defRPr sz="1200" b="1">
-                <a:solidFill>
-                  <a:srgbClr val="1A202C"/>
-                </a:solidFill>
-                <a:latin typeface="Microsoft YaHei"/>
+              <a:defRPr sz="1100" b="1">
+                <a:solidFill>
+                  <a:srgbClr val="000000"/>
+                </a:solidFill>
+                <a:latin typeface="Times New Roman"/>
               </a:defRPr>
             </a:pPr>
             <a:r>
-              <a:t>L2: 空间与表达层 (Spatial &amp; Data Representation Domain)   │   对应章节: 第 4 章 (3D重建) &amp; 第 5 章 (巡检数据集)</a:t>
-            </a:r>
-          </a:p>
-          <a:p>
-            <a:pPr>
-              <a:defRPr sz="1050">
-                <a:solidFill>
-                  <a:srgbClr val="4A5568"/>
-                </a:solidFill>
-                <a:latin typeface="Microsoft YaHei"/>
-              </a:defRPr>
-            </a:pPr>
-            <a:r>
-              <a:t>核心功能组件: 无人机倾斜摄影测量 • 点云与三维网格建模 (Mesh) • BIM/地理坐标对齐 • 多模态 (RGB/热成像) 数据集构建与标定</a:t>
-            </a:r>
-          </a:p>
-        </p:txBody>
-      </p:sp>
-      <p:sp>
-        <p:nvSpPr>
-          <p:cNvPr id="8" name="Down Arrow 7"/>
+              <a:t>Phase II: Reconstruction &amp; Data</a:t>
+            </a:r>
+          </a:p>
+        </p:txBody>
+      </p:sp>
+      <p:sp>
+        <p:nvSpPr>
+          <p:cNvPr id="8" name="Rectangle 7"/>
           <p:cNvSpPr/>
           <p:nvPr/>
         </p:nvSpPr>
         <p:spPr>
           <a:xfrm>
-            <a:off x="5852160" y="4818888"/>
-            <a:ext cx="228600" cy="100584"/>
-          </a:xfrm>
-          <a:prstGeom prst="downArrow">
+            <a:off x="3502152" y="1920240"/>
+            <a:ext cx="2423160" cy="2002536"/>
+          </a:xfrm>
+          <a:prstGeom prst="rect">
             <a:avLst/>
           </a:prstGeom>
           <a:solidFill>
-            <a:srgbClr val="4A5568"/>
+            <a:srgbClr val="FFFFFF"/>
           </a:solidFill>
-          <a:ln>
-            <a:noFill/>
+          <a:ln w="12700">
+            <a:solidFill>
+              <a:srgbClr val="000000"/>
+            </a:solidFill>
           </a:ln>
         </p:spPr>
         <p:style>
@@ -5368,10 +4535,40 @@
           </a:fontRef>
         </p:style>
         <p:txBody>
-          <a:bodyPr rtlCol="0" anchor="ctr"/>
-          <a:lstStyle/>
-          <a:p>
-            <a:pPr algn="ctr"/>
+          <a:bodyPr rtlCol="0" anchor="t" wrap="square" lIns="109728" rIns="109728" tIns="109728"/>
+          <a:lstStyle/>
+          <a:p>
+            <a:pPr algn="ctr">
+              <a:spcAft>
+                <a:spcPts val="400"/>
+              </a:spcAft>
+              <a:defRPr sz="1050" b="1">
+                <a:solidFill>
+                  <a:srgbClr val="000000"/>
+                </a:solidFill>
+                <a:latin typeface="Times New Roman"/>
+              </a:defRPr>
+            </a:pPr>
+            <a:r>
+              <a:t>Chapter 4: 3D Reconstruction</a:t>
+            </a:r>
+          </a:p>
+          <a:p>
+            <a:pPr>
+              <a:defRPr sz="950">
+                <a:solidFill>
+                  <a:srgbClr val="000000"/>
+                </a:solidFill>
+                <a:latin typeface="Times New Roman"/>
+              </a:defRPr>
+            </a:pPr>
+            <a:r>
+              <a:t>• Photogrammetry &amp; point clouds</a:t>
+            </a:r>
+            <a:br/>
+            <a:r>
+              <a:t>• Mesh modeling &amp; BIM alignment</a:t>
+            </a:r>
           </a:p>
         </p:txBody>
       </p:sp>
@@ -5383,18 +4580,18 @@
         </p:nvSpPr>
         <p:spPr>
           <a:xfrm>
-            <a:off x="731520" y="4937760"/>
-            <a:ext cx="10728655" cy="1051560"/>
+            <a:off x="3502152" y="4032504"/>
+            <a:ext cx="2423160" cy="2002536"/>
           </a:xfrm>
           <a:prstGeom prst="rect">
             <a:avLst/>
           </a:prstGeom>
           <a:solidFill>
-            <a:srgbClr val="F8FAFC"/>
+            <a:srgbClr val="FFFFFF"/>
           </a:solidFill>
-          <a:ln w="19050">
+          <a:ln w="12700">
             <a:solidFill>
-              <a:srgbClr val="94A3B8"/>
+              <a:srgbClr val="000000"/>
             </a:solidFill>
           </a:ln>
         </p:spPr>
@@ -5413,32 +4610,575 @@
           </a:fontRef>
         </p:style>
         <p:txBody>
-          <a:bodyPr rtlCol="0" anchor="ctr" wrap="square" lIns="182880" rIns="182880" tIns="91440" bIns="91440"/>
+          <a:bodyPr rtlCol="0" anchor="t" wrap="square" lIns="109728" rIns="109728" tIns="109728"/>
           <a:lstStyle/>
           <a:p>
             <a:pPr algn="ctr">
-              <a:defRPr sz="1200" b="1">
-                <a:solidFill>
-                  <a:srgbClr val="1A202C"/>
-                </a:solidFill>
-                <a:latin typeface="Microsoft YaHei"/>
+              <a:spcAft>
+                <a:spcPts val="400"/>
+              </a:spcAft>
+              <a:defRPr sz="1050" b="1">
+                <a:solidFill>
+                  <a:srgbClr val="000000"/>
+                </a:solidFill>
+                <a:latin typeface="Times New Roman"/>
               </a:defRPr>
             </a:pPr>
             <a:r>
-              <a:t>L1: 物理与采集层 (Physical &amp; Flight Domain)   │   对应章节: 第 2 章 (任务规划) &amp; 第 3 章 (运动规划与执行)</a:t>
+              <a:t>Chapter 5: Inspection Datasets</a:t>
             </a:r>
           </a:p>
           <a:p>
             <a:pPr>
-              <a:defRPr sz="1050">
-                <a:solidFill>
-                  <a:srgbClr val="4A5568"/>
-                </a:solidFill>
-                <a:latin typeface="Microsoft YaHei"/>
+              <a:defRPr sz="950">
+                <a:solidFill>
+                  <a:srgbClr val="000000"/>
+                </a:solidFill>
+                <a:latin typeface="Times New Roman"/>
               </a:defRPr>
             </a:pPr>
             <a:r>
-              <a:t>核心功能组件: 立面巡检覆盖路径规划 • 实时避障与安全边界 • 轨迹优化控制 • 风场扰动控制 • 无人机平台与多传感器硬件执行</a:t>
+              <a:t>• Multimodal RGB / Thermal capture</a:t>
+            </a:r>
+            <a:br/>
+            <a:r>
+              <a:t>• Defect annotation &amp; benchmarks</a:t>
+            </a:r>
+          </a:p>
+        </p:txBody>
+      </p:sp>
+      <p:sp>
+        <p:nvSpPr>
+          <p:cNvPr id="10" name="Right Arrow 9"/>
+          <p:cNvSpPr/>
+          <p:nvPr/>
+        </p:nvSpPr>
+        <p:spPr>
+          <a:xfrm>
+            <a:off x="5998464" y="3593592"/>
+            <a:ext cx="201168" cy="219456"/>
+          </a:xfrm>
+          <a:prstGeom prst="rightArrow">
+            <a:avLst/>
+          </a:prstGeom>
+          <a:solidFill>
+            <a:srgbClr val="000000"/>
+          </a:solidFill>
+          <a:ln>
+            <a:noFill/>
+          </a:ln>
+        </p:spPr>
+        <p:style>
+          <a:lnRef idx="1">
+            <a:schemeClr val="accent1"/>
+          </a:lnRef>
+          <a:fillRef idx="3">
+            <a:schemeClr val="accent1"/>
+          </a:fillRef>
+          <a:effectRef idx="2">
+            <a:schemeClr val="accent1"/>
+          </a:effectRef>
+          <a:fontRef idx="minor">
+            <a:schemeClr val="lt1"/>
+          </a:fontRef>
+        </p:style>
+        <p:txBody>
+          <a:bodyPr rtlCol="0" anchor="ctr"/>
+          <a:lstStyle/>
+          <a:p>
+            <a:pPr algn="ctr"/>
+          </a:p>
+        </p:txBody>
+      </p:sp>
+      <p:sp>
+        <p:nvSpPr>
+          <p:cNvPr id="11" name="Rectangle 10"/>
+          <p:cNvSpPr/>
+          <p:nvPr/>
+        </p:nvSpPr>
+        <p:spPr>
+          <a:xfrm>
+            <a:off x="6272784" y="1371600"/>
+            <a:ext cx="2423160" cy="457200"/>
+          </a:xfrm>
+          <a:prstGeom prst="rect">
+            <a:avLst/>
+          </a:prstGeom>
+          <a:solidFill>
+            <a:srgbClr val="FFFFFF"/>
+          </a:solidFill>
+          <a:ln w="15875">
+            <a:solidFill>
+              <a:srgbClr val="000000"/>
+            </a:solidFill>
+          </a:ln>
+        </p:spPr>
+        <p:style>
+          <a:lnRef idx="1">
+            <a:schemeClr val="accent1"/>
+          </a:lnRef>
+          <a:fillRef idx="3">
+            <a:schemeClr val="accent1"/>
+          </a:fillRef>
+          <a:effectRef idx="2">
+            <a:schemeClr val="accent1"/>
+          </a:effectRef>
+          <a:fontRef idx="minor">
+            <a:schemeClr val="lt1"/>
+          </a:fontRef>
+        </p:style>
+        <p:txBody>
+          <a:bodyPr rtlCol="0" anchor="ctr"/>
+          <a:lstStyle/>
+          <a:p>
+            <a:pPr algn="ctr">
+              <a:defRPr sz="1100" b="1">
+                <a:solidFill>
+                  <a:srgbClr val="000000"/>
+                </a:solidFill>
+                <a:latin typeface="Times New Roman"/>
+              </a:defRPr>
+            </a:pPr>
+            <a:r>
+              <a:t>Phase III: AI Defect Perception</a:t>
+            </a:r>
+          </a:p>
+        </p:txBody>
+      </p:sp>
+      <p:sp>
+        <p:nvSpPr>
+          <p:cNvPr id="12" name="Rectangle 11"/>
+          <p:cNvSpPr/>
+          <p:nvPr/>
+        </p:nvSpPr>
+        <p:spPr>
+          <a:xfrm>
+            <a:off x="6272784" y="1920240"/>
+            <a:ext cx="2423160" cy="4114800"/>
+          </a:xfrm>
+          <a:prstGeom prst="rect">
+            <a:avLst/>
+          </a:prstGeom>
+          <a:solidFill>
+            <a:srgbClr val="FFFFFF"/>
+          </a:solidFill>
+          <a:ln w="12700">
+            <a:solidFill>
+              <a:srgbClr val="000000"/>
+            </a:solidFill>
+          </a:ln>
+        </p:spPr>
+        <p:style>
+          <a:lnRef idx="1">
+            <a:schemeClr val="accent1"/>
+          </a:lnRef>
+          <a:fillRef idx="3">
+            <a:schemeClr val="accent1"/>
+          </a:fillRef>
+          <a:effectRef idx="2">
+            <a:schemeClr val="accent1"/>
+          </a:effectRef>
+          <a:fontRef idx="minor">
+            <a:schemeClr val="lt1"/>
+          </a:fontRef>
+        </p:style>
+        <p:txBody>
+          <a:bodyPr rtlCol="0" anchor="t" wrap="square" lIns="109728" rIns="109728" tIns="109728"/>
+          <a:lstStyle/>
+          <a:p>
+            <a:pPr algn="ctr">
+              <a:spcAft>
+                <a:spcPts val="400"/>
+              </a:spcAft>
+              <a:defRPr sz="1050" b="1">
+                <a:solidFill>
+                  <a:srgbClr val="000000"/>
+                </a:solidFill>
+                <a:latin typeface="Times New Roman"/>
+              </a:defRPr>
+            </a:pPr>
+            <a:r>
+              <a:t>Chapter 6: AI Defect Models</a:t>
+            </a:r>
+          </a:p>
+          <a:p>
+            <a:pPr>
+              <a:defRPr sz="950">
+                <a:solidFill>
+                  <a:srgbClr val="000000"/>
+                </a:solidFill>
+                <a:latin typeface="Times New Roman"/>
+              </a:defRPr>
+            </a:pPr>
+            <a:r>
+              <a:t>• Deep learning defect detection</a:t>
+            </a:r>
+            <a:br/>
+            <a:r>
+              <a:t>• Instance segmentation &amp; quantification</a:t>
+            </a:r>
+            <a:br/>
+            <a:r>
+              <a:t>• Severity rating</a:t>
+            </a:r>
+          </a:p>
+        </p:txBody>
+      </p:sp>
+      <p:sp>
+        <p:nvSpPr>
+          <p:cNvPr id="13" name="Right Arrow 12"/>
+          <p:cNvSpPr/>
+          <p:nvPr/>
+        </p:nvSpPr>
+        <p:spPr>
+          <a:xfrm>
+            <a:off x="8769096" y="3593592"/>
+            <a:ext cx="201168" cy="219456"/>
+          </a:xfrm>
+          <a:prstGeom prst="rightArrow">
+            <a:avLst/>
+          </a:prstGeom>
+          <a:solidFill>
+            <a:srgbClr val="000000"/>
+          </a:solidFill>
+          <a:ln>
+            <a:noFill/>
+          </a:ln>
+        </p:spPr>
+        <p:style>
+          <a:lnRef idx="1">
+            <a:schemeClr val="accent1"/>
+          </a:lnRef>
+          <a:fillRef idx="3">
+            <a:schemeClr val="accent1"/>
+          </a:fillRef>
+          <a:effectRef idx="2">
+            <a:schemeClr val="accent1"/>
+          </a:effectRef>
+          <a:fontRef idx="minor">
+            <a:schemeClr val="lt1"/>
+          </a:fontRef>
+        </p:style>
+        <p:txBody>
+          <a:bodyPr rtlCol="0" anchor="ctr"/>
+          <a:lstStyle/>
+          <a:p>
+            <a:pPr algn="ctr"/>
+          </a:p>
+        </p:txBody>
+      </p:sp>
+      <p:sp>
+        <p:nvSpPr>
+          <p:cNvPr id="14" name="Rectangle 13"/>
+          <p:cNvSpPr/>
+          <p:nvPr/>
+        </p:nvSpPr>
+        <p:spPr>
+          <a:xfrm>
+            <a:off x="9043416" y="1371600"/>
+            <a:ext cx="2423160" cy="457200"/>
+          </a:xfrm>
+          <a:prstGeom prst="rect">
+            <a:avLst/>
+          </a:prstGeom>
+          <a:solidFill>
+            <a:srgbClr val="FFFFFF"/>
+          </a:solidFill>
+          <a:ln w="15875">
+            <a:solidFill>
+              <a:srgbClr val="000000"/>
+            </a:solidFill>
+          </a:ln>
+        </p:spPr>
+        <p:style>
+          <a:lnRef idx="1">
+            <a:schemeClr val="accent1"/>
+          </a:lnRef>
+          <a:fillRef idx="3">
+            <a:schemeClr val="accent1"/>
+          </a:fillRef>
+          <a:effectRef idx="2">
+            <a:schemeClr val="accent1"/>
+          </a:effectRef>
+          <a:fontRef idx="minor">
+            <a:schemeClr val="lt1"/>
+          </a:fontRef>
+        </p:style>
+        <p:txBody>
+          <a:bodyPr rtlCol="0" anchor="ctr"/>
+          <a:lstStyle/>
+          <a:p>
+            <a:pPr algn="ctr">
+              <a:defRPr sz="1100" b="1">
+                <a:solidFill>
+                  <a:srgbClr val="000000"/>
+                </a:solidFill>
+                <a:latin typeface="Times New Roman"/>
+              </a:defRPr>
+            </a:pPr>
+            <a:r>
+              <a:t>Phase IV: Digital Twin &amp; LLM</a:t>
+            </a:r>
+          </a:p>
+        </p:txBody>
+      </p:sp>
+      <p:sp>
+        <p:nvSpPr>
+          <p:cNvPr id="15" name="Rectangle 14"/>
+          <p:cNvSpPr/>
+          <p:nvPr/>
+        </p:nvSpPr>
+        <p:spPr>
+          <a:xfrm>
+            <a:off x="9043416" y="1920240"/>
+            <a:ext cx="2423160" cy="1298448"/>
+          </a:xfrm>
+          <a:prstGeom prst="rect">
+            <a:avLst/>
+          </a:prstGeom>
+          <a:solidFill>
+            <a:srgbClr val="FFFFFF"/>
+          </a:solidFill>
+          <a:ln w="12700">
+            <a:solidFill>
+              <a:srgbClr val="000000"/>
+            </a:solidFill>
+          </a:ln>
+        </p:spPr>
+        <p:style>
+          <a:lnRef idx="1">
+            <a:schemeClr val="accent1"/>
+          </a:lnRef>
+          <a:fillRef idx="3">
+            <a:schemeClr val="accent1"/>
+          </a:fillRef>
+          <a:effectRef idx="2">
+            <a:schemeClr val="accent1"/>
+          </a:effectRef>
+          <a:fontRef idx="minor">
+            <a:schemeClr val="lt1"/>
+          </a:fontRef>
+        </p:style>
+        <p:txBody>
+          <a:bodyPr rtlCol="0" anchor="t" wrap="square" lIns="109728" rIns="109728" tIns="109728"/>
+          <a:lstStyle/>
+          <a:p>
+            <a:pPr algn="ctr">
+              <a:spcAft>
+                <a:spcPts val="400"/>
+              </a:spcAft>
+              <a:defRPr sz="1050" b="1">
+                <a:solidFill>
+                  <a:srgbClr val="000000"/>
+                </a:solidFill>
+                <a:latin typeface="Times New Roman"/>
+              </a:defRPr>
+            </a:pPr>
+            <a:r>
+              <a:t>Chapter 7: GIS &amp; GeoBIM</a:t>
+            </a:r>
+          </a:p>
+          <a:p>
+            <a:pPr>
+              <a:defRPr sz="950">
+                <a:solidFill>
+                  <a:srgbClr val="000000"/>
+                </a:solidFill>
+                <a:latin typeface="Times New Roman"/>
+              </a:defRPr>
+            </a:pPr>
+            <a:r>
+              <a:t>• Spatial database &amp; GeoBIM mapping</a:t>
+            </a:r>
+            <a:br/>
+            <a:r>
+              <a:t>• Defect &amp; Asset Passport attachment</a:t>
+            </a:r>
+          </a:p>
+        </p:txBody>
+      </p:sp>
+      <p:sp>
+        <p:nvSpPr>
+          <p:cNvPr id="16" name="Rectangle 15"/>
+          <p:cNvSpPr/>
+          <p:nvPr/>
+        </p:nvSpPr>
+        <p:spPr>
+          <a:xfrm>
+            <a:off x="9043416" y="3328416"/>
+            <a:ext cx="2423160" cy="1298448"/>
+          </a:xfrm>
+          <a:prstGeom prst="rect">
+            <a:avLst/>
+          </a:prstGeom>
+          <a:solidFill>
+            <a:srgbClr val="FFFFFF"/>
+          </a:solidFill>
+          <a:ln w="12700">
+            <a:solidFill>
+              <a:srgbClr val="000000"/>
+            </a:solidFill>
+          </a:ln>
+        </p:spPr>
+        <p:style>
+          <a:lnRef idx="1">
+            <a:schemeClr val="accent1"/>
+          </a:lnRef>
+          <a:fillRef idx="3">
+            <a:schemeClr val="accent1"/>
+          </a:fillRef>
+          <a:effectRef idx="2">
+            <a:schemeClr val="accent1"/>
+          </a:effectRef>
+          <a:fontRef idx="minor">
+            <a:schemeClr val="lt1"/>
+          </a:fontRef>
+        </p:style>
+        <p:txBody>
+          <a:bodyPr rtlCol="0" anchor="t" wrap="square" lIns="109728" rIns="109728" tIns="109728"/>
+          <a:lstStyle/>
+          <a:p>
+            <a:pPr algn="ctr">
+              <a:spcAft>
+                <a:spcPts val="400"/>
+              </a:spcAft>
+              <a:defRPr sz="1050" b="1">
+                <a:solidFill>
+                  <a:srgbClr val="000000"/>
+                </a:solidFill>
+                <a:latin typeface="Times New Roman"/>
+              </a:defRPr>
+            </a:pPr>
+            <a:r>
+              <a:t>Chapter 8: Digital Twin &amp; LLM</a:t>
+            </a:r>
+          </a:p>
+          <a:p>
+            <a:pPr>
+              <a:defRPr sz="950">
+                <a:solidFill>
+                  <a:srgbClr val="000000"/>
+                </a:solidFill>
+                <a:latin typeface="Times New Roman"/>
+              </a:defRPr>
+            </a:pPr>
+            <a:r>
+              <a:t>• LLM / VLM RAG reasoning</a:t>
+            </a:r>
+            <a:br/>
+            <a:r>
+              <a:t>• Maintenance query &amp; decision support</a:t>
+            </a:r>
+          </a:p>
+        </p:txBody>
+      </p:sp>
+      <p:sp>
+        <p:nvSpPr>
+          <p:cNvPr id="17" name="Rectangle 16"/>
+          <p:cNvSpPr/>
+          <p:nvPr/>
+        </p:nvSpPr>
+        <p:spPr>
+          <a:xfrm>
+            <a:off x="9043416" y="4736592"/>
+            <a:ext cx="2423160" cy="1298448"/>
+          </a:xfrm>
+          <a:prstGeom prst="rect">
+            <a:avLst/>
+          </a:prstGeom>
+          <a:solidFill>
+            <a:srgbClr val="FFFFFF"/>
+          </a:solidFill>
+          <a:ln w="12700">
+            <a:solidFill>
+              <a:srgbClr val="000000"/>
+            </a:solidFill>
+          </a:ln>
+        </p:spPr>
+        <p:style>
+          <a:lnRef idx="1">
+            <a:schemeClr val="accent1"/>
+          </a:lnRef>
+          <a:fillRef idx="3">
+            <a:schemeClr val="accent1"/>
+          </a:fillRef>
+          <a:effectRef idx="2">
+            <a:schemeClr val="accent1"/>
+          </a:effectRef>
+          <a:fontRef idx="minor">
+            <a:schemeClr val="lt1"/>
+          </a:fontRef>
+        </p:style>
+        <p:txBody>
+          <a:bodyPr rtlCol="0" anchor="t" wrap="square" lIns="109728" rIns="109728" tIns="109728"/>
+          <a:lstStyle/>
+          <a:p>
+            <a:pPr algn="ctr">
+              <a:spcAft>
+                <a:spcPts val="400"/>
+              </a:spcAft>
+              <a:defRPr sz="1050" b="1">
+                <a:solidFill>
+                  <a:srgbClr val="000000"/>
+                </a:solidFill>
+                <a:latin typeface="Times New Roman"/>
+              </a:defRPr>
+            </a:pPr>
+            <a:r>
+              <a:t>Chapter 9: Conclusion &amp; Future</a:t>
+            </a:r>
+          </a:p>
+          <a:p>
+            <a:pPr>
+              <a:defRPr sz="950">
+                <a:solidFill>
+                  <a:srgbClr val="000000"/>
+                </a:solidFill>
+                <a:latin typeface="Times New Roman"/>
+              </a:defRPr>
+            </a:pPr>
+            <a:r>
+              <a:t>• Field deployment audit</a:t>
+            </a:r>
+            <a:br/>
+            <a:r>
+              <a:t>• Open challenges &amp; future outlook</a:t>
+            </a:r>
+          </a:p>
+        </p:txBody>
+      </p:sp>
+      <p:sp>
+        <p:nvSpPr>
+          <p:cNvPr id="18" name="TextBox 17"/>
+          <p:cNvSpPr txBox="1"/>
+          <p:nvPr/>
+        </p:nvSpPr>
+        <p:spPr>
+          <a:xfrm>
+            <a:off x="731520" y="6217920"/>
+            <a:ext cx="10728655" cy="365760"/>
+          </a:xfrm>
+          <a:prstGeom prst="rect">
+            <a:avLst/>
+          </a:prstGeom>
+          <a:noFill/>
+        </p:spPr>
+        <p:txBody>
+          <a:bodyPr wrap="none">
+            <a:spAutoFit/>
+          </a:bodyPr>
+          <a:lstStyle/>
+          <a:p>
+            <a:pPr>
+              <a:defRPr sz="1000" b="1">
+                <a:solidFill>
+                  <a:srgbClr val="000000"/>
+                </a:solidFill>
+                <a:latin typeface="Times New Roman"/>
+              </a:defRPr>
+            </a:pPr>
+            <a:r>
+              <a:t>Figure 1.1: End-to-end four-phase methodology and chapter mapping of the monograph.</a:t>
             </a:r>
           </a:p>
         </p:txBody>

</xml_diff>